<commit_message>
feat: bring model migration evaluation strategy to life
- export normalized Foundry evaluation artifacts and provenance
- add deterministic contract checks and offline promotion policies
- enhance datasets and CI comparison workflows
- document live smoke testing and migration lab workflows
- update workshop deck with evidence, gating, and migration guidance
</commit_message>
<xml_diff>
--- a/slides/foundry-evals-workshop-deck.pptx
+++ b/slides/foundry-evals-workshop-deck.pptx
@@ -23,6 +23,7 @@
     <p:sldId id="268" r:id="rId14"/>
     <p:sldId id="269" r:id="rId15"/>
     <p:sldId id="270" r:id="rId16"/>
+    <p:sldId id="277" r:id="rId28"/>
     <p:sldId id="271" r:id="rId17"/>
     <p:sldId id="272" r:id="rId18"/>
     <p:sldId id="273" r:id="rId19"/>
@@ -389,8 +390,7 @@
           <a:lstStyle/>
           <a:p>
             <a:r>
-              <a:rPr lang="en-US" dirty="0"/>
-              <a:t>The most common Partial-status cause all day will be someone mapping output_text where a tool evaluator needed output_items, or a case mismatch against the JSONL. AI-assisted evaluators also need the judge deployment name in initialization_parameters.</a:t>
+              <a:t>The most common Partial-status cause is a case-sensitive field mismatch or mapping the wrong response shape. In this repo, agent/process evaluators consume sample.output_messages: role-bearing messages containing tool calls and tool results. sample.output_text is only the final text. sample.output_items is retained as raw Responses API data for inspection, not consumed by these evaluators. AI-assisted evaluators also need the configured judge deployment where required.</a:t>
             </a:r>
           </a:p>
         </p:txBody>
@@ -476,8 +476,7 @@
           <a:lstStyle/>
           <a:p>
             <a:r>
-              <a:rPr lang="en-US" dirty="0"/>
-              <a:t>The adversarial dataset rows ('book me a flight', prompt injection) exist to make Intent Resolution and abstention interesting. Same target pattern also evaluates third-party agents — LangGraph, A2A, any HTTP framework. Invocations-protocol hosted agents need freeform input_messages instead of the template.</a:t>
+              <a:t>The workshop prompt agent stores schemas in Foundry but executes get_weather/get_forecast in the local runner. Demonstrate one query first, then the batch. check_contracts.py is deterministic: it catches unknown tools, malformed/non-object arguments, missing required parameters, primitive type mismatches, expected calls, and expect_no_tool violations. Only after contracts pass do we ask Foundry's judge-based evaluators about intent, task adherence, and tool-call quality. For GxP, Task Adherence is a proxy until the optional ALCOA+ rubric is registered.</a:t>
             </a:r>
           </a:p>
         </p:txBody>
@@ -650,8 +649,7 @@
           <a:lstStyle/>
           <a:p>
             <a:r>
-              <a:rPr lang="en-US" dirty="0"/>
-              <a:t>Discussion prompt: what's your merge gate — hard threshold per evaluator or regression vs baseline using the pairwise comparison? Entra-only auth via ARM service connection lands well with locked-down estates.</a:t>
+              <a:t>Do not conflate a rendered comparison report with a merge-blocking policy gate. The official Azure DevOps task and GitHub action are the native comparison path for hosted agents whose tools execute in the service; Foundry supplies confidence intervals and pairwise significance. Public documentation does not promise machine-readable threshold outputs. This repo's enforcing workflows exist because workshop tools execute locally: generate both response sets, run deterministic contract checks, score under one immutable evaluation group, then apply explicit policy. Foundry remains the statistics authority. Both paths use Entra ID/OIDC, publish evidence on failure, and leave baseline promotion to review.</a:t>
             </a:r>
           </a:p>
         </p:txBody>
@@ -1346,8 +1344,7 @@
           <a:lstStyle/>
           <a:p>
             <a:r>
-              <a:rPr lang="en-US" dirty="0"/>
-              <a:t>Roadmap caveat to say out loud: hosted-agent tracing/eval GA is expected right about now (June/July 2026) — verify current status before quoting it. Preview features shown today: Rubric evaluator, trace-based eval for external agents, continuous-eval custom evaluators, Agent Monitoring Dashboard.</a:t>
+              <a:t>Close on the complete evidence chain. A live deployment smoke test proves the deployed agent can execute. Deterministic contracts prove tool calls satisfy the application schema. Foundry evaluators assess intent, process, safety, and response quality. The repository policy gate turns that evidence into explicit pass, fail, or review-required outcomes, while Foundry remains the source for statistical significance. None of this removes human ownership: judge changes need overlap and re-baselining, and promotion is a reviewed decision.</a:t>
             </a:r>
           </a:p>
         </p:txBody>
@@ -1475,6 +1472,52 @@
 </p:notes>
 </file>
 
+<file path=ppt/notesSlides/notesSlide22.xml><?xml version="1.0" encoding="utf-8"?>
+<p:notes xmlns:a="http://schemas.openxmlformats.org/drawingml/2006/main" xmlns:p="http://schemas.openxmlformats.org/presentationml/2006/main" xmlns:r="http://schemas.openxmlformats.org/officeDocument/2006/relationships">
+  <p:cSld>
+    <p:spTree>
+      <p:nvGrpSpPr>
+        <p:cNvPr id="1" name=""/>
+        <p:cNvGrpSpPr/>
+        <p:nvPr/>
+      </p:nvGrpSpPr>
+      <p:grpSpPr>
+        <a:xfrm>
+          <a:off x="0" y="0"/>
+          <a:ext cx="0" cy="0"/>
+          <a:chOff x="0" y="0"/>
+          <a:chExt cx="0" cy="0"/>
+        </a:xfrm>
+      </p:grpSpPr>
+      <p:sp>
+        <p:nvSpPr>
+          <p:cNvPr id="3" name="Notes Placeholder 2"/>
+          <p:cNvSpPr>
+            <a:spLocks noGrp="1"/>
+          </p:cNvSpPr>
+          <p:nvPr>
+            <p:ph type="body" idx="1"/>
+          </p:nvPr>
+        </p:nvSpPr>
+        <p:spPr/>
+        <p:txBody>
+          <a:bodyPr/>
+          <a:lstStyle/>
+          <a:p>
+            <a:r>
+              <a:t>Optional 35–45 minute Lab 3; use it instead of the local-evaluation stretch or as take-home work. Create incumbent and candidate versions, run both against the same 20-row dataset, validate contracts, and reuse the incumbent evaluation ID for the candidate. Inspect Foundry's confidence intervals and pairwise comparison before running eval_gate.py. Exit 0 is pass, 1 is policy failure, and 2 is review_required for incomplete or incompatible evidence. A 20-row teaching set may be statistically inconclusive; that is an honest outcome. Never auto-promote the candidate. For GxP, use one discipline and review decision_refusal and data_integrity_trap first.</a:t>
+            </a:r>
+          </a:p>
+        </p:txBody>
+      </p:sp>
+    </p:spTree>
+  </p:cSld>
+  <p:clrMapOvr>
+    <a:masterClrMapping/>
+  </p:clrMapOvr>
+</p:notes>
+</file>
+
 <file path=ppt/notesSlides/notesSlide3.xml><?xml version="1.0" encoding="utf-8"?>
 <p:notes xmlns:a="http://schemas.openxmlformats.org/drawingml/2006/main" xmlns:r="http://schemas.openxmlformats.org/officeDocument/2006/relationships" xmlns:p="http://schemas.openxmlformats.org/presentationml/2006/main">
   <p:cSld>
@@ -2042,8 +2085,7 @@
           <a:lstStyle/>
           <a:p>
             <a:r>
-              <a:rPr lang="en-US" dirty="0"/>
-              <a:t>Stagger submissions by table to dodge rate limits. While portal runs complete, walk the status semantics. Fast finishers: run_local_eval.py, then compare local vs cloud primitives.</a:t>
+              <a:t>Start with the named live Foundry deployment smoke test: check_setup.py verifies project access and the judge deployment; create_agent.py creates a real prompt-agent version; run_agent.py --query invokes that deployed version and executes its local Python tools. Success means a tool call, tool result, and grounded final response. Then use precomputed responses for cloud evaluation because Foundry's service-side live target cannot execute these workshop-local Python functions. The SDK run exports run.json, output-items.jsonl, and summary.json. Stagger cloud submissions by table to reduce 429 pressure.</a:t>
             </a:r>
           </a:p>
         </p:txBody>
@@ -3363,7 +3405,7 @@
                 <a:ea typeface="Courier New" pitchFamily="34" charset="-122"/>
                 <a:cs typeface="Courier New" pitchFamily="34" charset="-120"/>
               </a:rPr>
-              <a:t>{{sample.output_items}}</a:t>
+              <a:t>{{sample.output_messages}}</a:t>
             </a:r>
             <a:endParaRPr lang="en-US" sz="1200" dirty="0"/>
           </a:p>
@@ -3402,7 +3444,7 @@
                 <a:ea typeface="Calibri" pitchFamily="34" charset="-122"/>
                 <a:cs typeface="Calibri" pitchFamily="34" charset="-120"/>
               </a:rPr>
-              <a:t>The FULL response including tool calls — required for the process evaluators</a:t>
+              <a:t>Role-bearing conversation with tool calls + results — use for agent/process evaluators</a:t>
             </a:r>
             <a:endParaRPr lang="en-US" sz="1200" dirty="0"/>
           </a:p>
@@ -3513,7 +3555,7 @@
                 <a:ea typeface="Cambria" pitchFamily="34" charset="-122"/>
                 <a:cs typeface="Cambria" pitchFamily="34" charset="-120"/>
               </a:rPr>
-              <a:t>Lab 2 — Judge a live agent, then extend the catalog</a:t>
+              <a:t>Lab 2 — Execute the agent, check contracts, then extend</a:t>
             </a:r>
             <a:endParaRPr lang="en-US" sz="3000" dirty="0"/>
           </a:p>
@@ -3639,7 +3681,7 @@
                 <a:ea typeface="Calibri" pitchFamily="34" charset="-122"/>
                 <a:cs typeface="Calibri" pitchFamily="34" charset="-120"/>
               </a:rPr>
-              <a:t>A — Evaluate the weather agent (20')</a:t>
+              <a:t>A — Live agent + contracts (20')</a:t>
             </a:r>
             <a:endParaRPr lang="en-US" sz="1300" dirty="0"/>
           </a:p>
@@ -3678,7 +3720,7 @@
                 <a:ea typeface="Calibri" pitchFamily="34" charset="-122"/>
                 <a:cs typeface="Calibri" pitchFamily="34" charset="-120"/>
               </a:rPr>
-              <a:t>azure_ai_target_completions sends each query to the live agent and scores the full response. Evaluators: Intent Resolution (system) + Tool Call Accuracy (process) + Task Adherence (system). Watch the adversarial rows.</a:t>
+              <a:t>run_agent.py executes the deployed agent and local tool loop. check_contracts.py hard-checks tool names, JSON arguments, required fields, types, and explicit no-tool cases before cloud scoring.</a:t>
             </a:r>
             <a:endParaRPr lang="en-US" sz="1050" dirty="0"/>
           </a:p>
@@ -3753,7 +3795,7 @@
                 <a:ea typeface="Calibri" pitchFamily="34" charset="-122"/>
                 <a:cs typeface="Calibri" pitchFamily="34" charset="-120"/>
               </a:rPr>
-              <a:t>B — Custom evaluators (10')</a:t>
+              <a:t>B — Cloud + custom evaluators (15')</a:t>
             </a:r>
             <a:endParaRPr lang="en-US" sz="1300" dirty="0"/>
           </a:p>
@@ -3792,7 +3834,7 @@
                 <a:ea typeface="Calibri" pitchFamily="34" charset="-122"/>
                 <a:cs typeface="Calibri" pitchFamily="34" charset="-120"/>
               </a:rPr>
-              <a:t>Prompt-based (a rubric for the judge) or code-based (deterministic Python, thresholds → pass/fail). Registered once in the evaluator catalog, they run in batch, portal AND continuous evaluation.</a:t>
+              <a:t>Score precomputed output_messages with Intent Resolution + Tool Call Accuracy + Task Adherence + Violence. Then add prompt- or code-based catalog evaluators.</a:t>
             </a:r>
             <a:endParaRPr lang="en-US" sz="1050" dirty="0"/>
           </a:p>
@@ -3867,7 +3909,7 @@
                 <a:ea typeface="Calibri" pitchFamily="34" charset="-122"/>
                 <a:cs typeface="Calibri" pitchFamily="34" charset="-120"/>
               </a:rPr>
-              <a:t>C — Trace-based demo (15')</a:t>
+              <a:t>C — Trace-based demo (10')</a:t>
             </a:r>
             <a:endParaRPr lang="en-US" sz="1300" dirty="0"/>
           </a:p>
@@ -3906,7 +3948,7 @@
                 <a:ea typeface="Calibri" pitchFamily="34" charset="-122"/>
                 <a:cs typeface="Calibri" pitchFamily="34" charset="-120"/>
               </a:rPr>
-              <a:t>Facilitator demo: evaluate what actually happened in production. Existing traces by date range, specific operation_Ids, or agent filter — with intelligent sampling.</a:t>
+              <a:t>Facilitator demo: evaluate production traces by date range, operation ID, or agent filter — same evaluator suite, intelligent sampling, no hand-curated dataset.</a:t>
             </a:r>
             <a:endParaRPr lang="en-US" sz="1050" dirty="0"/>
           </a:p>
@@ -3945,7 +3987,7 @@
                 <a:ea typeface="Calibri" pitchFamily="34" charset="-122"/>
                 <a:cs typeface="Calibri" pitchFamily="34" charset="-120"/>
               </a:rPr>
-              <a:t>Gotcha: unsupported tool types make tool evaluators emit “pass — not supported” so you can filter them; wrap them as user-defined tools to make them evaluable.</a:t>
+              <a:t>Contract failures are hard failures even when the LLM judge likes the final answer. Unsupported tool-evaluator evidence is missing evidence — never a free pass.</a:t>
             </a:r>
             <a:endParaRPr lang="en-US" sz="1100" dirty="0"/>
           </a:p>
@@ -4554,7 +4596,7 @@
                 <a:ea typeface="Cambria" pitchFamily="34" charset="-122"/>
                 <a:cs typeface="Cambria" pitchFamily="34" charset="-120"/>
               </a:rPr>
-              <a:t>Evaluation as a pipeline gate</a:t>
+              <a:t>Two honest patterns: native comparison vs. enforcing policy</a:t>
             </a:r>
             <a:endParaRPr lang="en-US" sz="3000" dirty="0"/>
           </a:p>
@@ -4629,7 +4671,7 @@
                 <a:ea typeface="Courier New" pitchFamily="34" charset="-122"/>
                 <a:cs typeface="Courier New" pitchFamily="34" charset="-120"/>
               </a:rPr>
-              <a:t>- task: AIAgentEvaluation@2</a:t>
+              <a:t>NATIVE COMPARISON · HOSTED AGENTS</a:t>
             </a:r>
             <a:endParaRPr lang="en-US" sz="1150" dirty="0"/>
           </a:p>
@@ -4640,15 +4682,14 @@
             <a:r>
               <a:rPr lang="en-US" sz="1150" dirty="0">
                 <a:solidFill>
-                  <a:srgbClr val="CADCFC"/>
+                  <a:srgbClr val="9EF0D2"/>
                 </a:solidFill>
                 <a:latin typeface="Courier New" pitchFamily="34" charset="0"/>
                 <a:ea typeface="Courier New" pitchFamily="34" charset="-122"/>
                 <a:cs typeface="Courier New" pitchFamily="34" charset="-120"/>
               </a:rPr>
-              <a:t>  inputs:</a:t>
-            </a:r>
-            <a:endParaRPr lang="en-US" sz="1150" dirty="0"/>
+              <a:t/>
+            </a:r>
           </a:p>
           <a:p>
             <a:pPr marL="0" indent="0">
@@ -4657,15 +4698,14 @@
             <a:r>
               <a:rPr lang="en-US" sz="1150" dirty="0">
                 <a:solidFill>
-                  <a:srgbClr val="CADCFC"/>
+                  <a:srgbClr val="9EF0D2"/>
                 </a:solidFill>
                 <a:latin typeface="Courier New" pitchFamily="34" charset="0"/>
                 <a:ea typeface="Courier New" pitchFamily="34" charset="-122"/>
                 <a:cs typeface="Courier New" pitchFamily="34" charset="-120"/>
               </a:rPr>
-              <a:t>    azure-ai-project-endpoint: $(Endpoint)</a:t>
-            </a:r>
-            <a:endParaRPr lang="en-US" sz="1150" dirty="0"/>
+              <a:t>AIAgentEvaluation@2</a:t>
+            </a:r>
           </a:p>
           <a:p>
             <a:pPr marL="0" indent="0">
@@ -4674,15 +4714,14 @@
             <a:r>
               <a:rPr lang="en-US" sz="1150" dirty="0">
                 <a:solidFill>
-                  <a:srgbClr val="CADCFC"/>
+                  <a:srgbClr val="9EF0D2"/>
                 </a:solidFill>
                 <a:latin typeface="Courier New" pitchFamily="34" charset="0"/>
                 <a:ea typeface="Courier New" pitchFamily="34" charset="-122"/>
                 <a:cs typeface="Courier New" pitchFamily="34" charset="-120"/>
               </a:rPr>
-              <a:t>    deployment-name: $(JudgeModel)</a:t>
-            </a:r>
-            <a:endParaRPr lang="en-US" sz="1150" dirty="0"/>
+              <a:t>microsoft/ai-agent-evals@v3-beta</a:t>
+            </a:r>
           </a:p>
           <a:p>
             <a:pPr marL="0" indent="0">
@@ -4691,15 +4730,14 @@
             <a:r>
               <a:rPr lang="en-US" sz="1150" dirty="0">
                 <a:solidFill>
-                  <a:srgbClr val="CADCFC"/>
+                  <a:srgbClr val="9EF0D2"/>
                 </a:solidFill>
                 <a:latin typeface="Courier New" pitchFamily="34" charset="0"/>
                 <a:ea typeface="Courier New" pitchFamily="34" charset="-122"/>
                 <a:cs typeface="Courier New" pitchFamily="34" charset="-120"/>
               </a:rPr>
-              <a:t>    data-path: evals/dataset.json</a:t>
-            </a:r>
-            <a:endParaRPr lang="en-US" sz="1150" dirty="0"/>
+              <a:t/>
+            </a:r>
           </a:p>
           <a:p>
             <a:pPr marL="0" indent="0">
@@ -4708,21 +4746,14 @@
             <a:r>
               <a:rPr lang="en-US" sz="1150" dirty="0">
                 <a:solidFill>
-                  <a:srgbClr val="CADCFC"/>
+                  <a:srgbClr val="9EF0D2"/>
                 </a:solidFill>
                 <a:latin typeface="Courier New" pitchFamily="34" charset="0"/>
                 <a:ea typeface="Courier New" pitchFamily="34" charset="-122"/>
                 <a:cs typeface="Courier New" pitchFamily="34" charset="-120"/>
               </a:rPr>
-              <a:t>    agent-ids: $(AgentIds)</a:t>
-            </a:r>
-            <a:endParaRPr lang="en-US" sz="1150" dirty="0"/>
-          </a:p>
-          <a:p>
-            <a:pPr marL="0" indent="0">
-              <a:buNone/>
-            </a:pPr>
-            <a:endParaRPr lang="en-US" sz="1150" dirty="0"/>
+              <a:t>agent-ids: name:version pairs</a:t>
+            </a:r>
           </a:p>
           <a:p>
             <a:pPr marL="0" indent="0">
@@ -4731,15 +4762,14 @@
             <a:r>
               <a:rPr lang="en-US" sz="1150" dirty="0">
                 <a:solidFill>
-                  <a:srgbClr val="8FA3D9"/>
+                  <a:srgbClr val="9EF0D2"/>
                 </a:solidFill>
                 <a:latin typeface="Courier New" pitchFamily="34" charset="0"/>
                 <a:ea typeface="Courier New" pitchFamily="34" charset="-122"/>
                 <a:cs typeface="Courier New" pitchFamily="34" charset="-120"/>
               </a:rPr>
-              <a:t># auth: Entra ID via ARM service</a:t>
-            </a:r>
-            <a:endParaRPr lang="en-US" sz="1150" dirty="0"/>
+              <a:t>baseline-agent-id: incumbent</a:t>
+            </a:r>
           </a:p>
           <a:p>
             <a:pPr marL="0" indent="0">
@@ -4748,15 +4778,30 @@
             <a:r>
               <a:rPr lang="en-US" sz="1150" dirty="0">
                 <a:solidFill>
-                  <a:srgbClr val="8FA3D9"/>
+                  <a:srgbClr val="9EF0D2"/>
                 </a:solidFill>
                 <a:latin typeface="Courier New" pitchFamily="34" charset="0"/>
                 <a:ea typeface="Courier New" pitchFamily="34" charset="-122"/>
                 <a:cs typeface="Courier New" pitchFamily="34" charset="-120"/>
               </a:rPr>
-              <a:t># connection - no keys in the pipeline</a:t>
-            </a:r>
-            <a:endParaRPr lang="en-US" sz="1150" dirty="0"/>
+              <a:t/>
+            </a:r>
+          </a:p>
+          <a:p>
+            <a:pPr marL="0" indent="0">
+              <a:buNone/>
+            </a:pPr>
+            <a:r>
+              <a:rPr lang="en-US" sz="1150" dirty="0">
+                <a:solidFill>
+                  <a:srgbClr val="9EF0D2"/>
+                </a:solidFill>
+                <a:latin typeface="Courier New" pitchFamily="34" charset="0"/>
+                <a:ea typeface="Courier New" pitchFamily="34" charset="-122"/>
+                <a:cs typeface="Courier New" pitchFamily="34" charset="-120"/>
+              </a:rPr>
+              <a:t>Entra ID / OIDC — no Foundry keys</a:t>
+            </a:r>
           </a:p>
         </p:txBody>
       </p:sp>
@@ -4829,7 +4874,7 @@
                 <a:ea typeface="Calibri" pitchFamily="34" charset="-122"/>
                 <a:cs typeface="Calibri" pitchFamily="34" charset="-120"/>
               </a:rPr>
-              <a:t>Confidence intervals, not vibes</a:t>
+              <a:t>Foundry owns the statistics</a:t>
             </a:r>
             <a:endParaRPr lang="en-US" sz="1250" dirty="0"/>
           </a:p>
@@ -4868,7 +4913,7 @@
                 <a:ea typeface="Calibri" pitchFamily="34" charset="-122"/>
                 <a:cs typeface="Calibri" pitchFamily="34" charset="-120"/>
               </a:rPr>
-              <a:t>The pipeline report shows per-metric scores with confidence intervals.</a:t>
+              <a:t>Rendered confidence intervals + pairwise comparison. Public contract does not define threshold outputs.</a:t>
             </a:r>
             <a:endParaRPr lang="en-US" sz="1000" dirty="0"/>
           </a:p>
@@ -4943,7 +4988,7 @@
                 <a:ea typeface="Calibri" pitchFamily="34" charset="-122"/>
                 <a:cs typeface="Calibri" pitchFamily="34" charset="-120"/>
               </a:rPr>
-              <a:t>Pairwise statistical comparison</a:t>
+              <a:t>Precomputed workflow enforces policy</a:t>
             </a:r>
             <a:endParaRPr lang="en-US" sz="1250" dirty="0"/>
           </a:p>
@@ -4982,7 +5027,7 @@
                 <a:ea typeface="Calibri" pitchFamily="34" charset="-122"/>
                 <a:cs typeface="Calibri" pitchFamily="34" charset="-120"/>
               </a:rPr>
-              <a:t>Evaluating two agent versions? It tells you whether the difference is meaningful or noise.</a:t>
+              <a:t>Run both versions → check contracts → score in one evaluation group → eval_gate.py.</a:t>
             </a:r>
             <a:endParaRPr lang="en-US" sz="1000" dirty="0"/>
           </a:p>
@@ -5057,7 +5102,7 @@
                 <a:ea typeface="Calibri" pitchFamily="34" charset="-122"/>
                 <a:cs typeface="Calibri" pitchFamily="34" charset="-120"/>
               </a:rPr>
-              <a:t>Sensible gating default</a:t>
+              <a:t>Explicit outcomes, reviewed promotion</a:t>
             </a:r>
             <a:endParaRPr lang="en-US" sz="1250" dirty="0"/>
           </a:p>
@@ -5096,7 +5141,7 @@
                 <a:ea typeface="Calibri" pitchFamily="34" charset="-122"/>
                 <a:cs typeface="Calibri" pitchFamily="34" charset="-120"/>
               </a:rPr>
-              <a:t>Safety evaluators = hard gates. Quality evaluators = regression-vs-baseline gates.</a:t>
+              <a:t>0 pass · 1 policy failure · 2 review_required. Safety hard gates; quality regression + cohort rules.</a:t>
             </a:r>
             <a:endParaRPr lang="en-US" sz="1000" dirty="0"/>
           </a:p>
@@ -5135,7 +5180,7 @@
                 <a:ea typeface="Calibri" pitchFamily="34" charset="-122"/>
                 <a:cs typeface="Calibri" pitchFamily="34" charset="-120"/>
               </a:rPr>
-              <a:t>GitHub Actions equivalent exists; VS Code (Foundry Toolkit) deploys with continuous evals via pytest — same evaluators everywhere.</a:t>
+              <a:t>Always publish evidence. Never auto-promote a baseline. Tiny smoke sets test connectivity; full sets compare versions.</a:t>
             </a:r>
             <a:endParaRPr lang="en-US" sz="1100" dirty="0"/>
           </a:p>
@@ -6404,6 +6449,747 @@
 </file>
 
 <file path=ppt/slides/slide16.xml><?xml version="1.0" encoding="utf-8"?>
+<p:sld xmlns:a="http://schemas.openxmlformats.org/drawingml/2006/main" xmlns:p="http://schemas.openxmlformats.org/presentationml/2006/main" xmlns:r="http://schemas.openxmlformats.org/officeDocument/2006/relationships">
+  <p:cSld>
+    <p:spTree>
+      <p:nvGrpSpPr>
+        <p:cNvPr id="1" name=""/>
+        <p:cNvGrpSpPr/>
+        <p:nvPr/>
+      </p:nvGrpSpPr>
+      <p:grpSpPr/>
+      <p:sp>
+        <p:nvSpPr>
+          <p:cNvPr id="2" name="Text 0"/>
+          <p:cNvSpPr/>
+          <p:nvPr/>
+        </p:nvSpPr>
+        <p:spPr>
+          <a:xfrm>
+            <a:off x="502920" y="274320"/>
+            <a:ext cx="8138160" cy="274320"/>
+          </a:xfrm>
+          <a:prstGeom prst="rect">
+            <a:avLst/>
+          </a:prstGeom>
+          <a:noFill/>
+          <a:ln/>
+        </p:spPr>
+        <p:txBody>
+          <a:bodyPr wrap="square" lIns="0" tIns="0" rIns="0" bIns="0" rtlCol="0" anchor="ctr"/>
+          <a:lstStyle/>
+          <a:p>
+            <a:pPr marL="0" indent="0">
+              <a:buNone/>
+            </a:pPr>
+            <a:r>
+              <a:rPr lang="en-US" sz="1100" b="1" kern="0" spc="300" dirty="0">
+                <a:solidFill>
+                  <a:srgbClr val="5A6378"/>
+                </a:solidFill>
+                <a:latin typeface="Calibri" pitchFamily="34" charset="0"/>
+                <a:ea typeface="Calibri" pitchFamily="34" charset="-122"/>
+                <a:cs typeface="Calibri" pitchFamily="34" charset="-120"/>
+              </a:rPr>
+              <a:t>OPTIONAL LAB · MODEL MIGRATION</a:t>
+            </a:r>
+            <a:endParaRPr lang="en-US" sz="1100" dirty="0"/>
+          </a:p>
+        </p:txBody>
+      </p:sp>
+      <p:sp>
+        <p:nvSpPr>
+          <p:cNvPr id="3" name="Text 1"/>
+          <p:cNvSpPr/>
+          <p:nvPr/>
+        </p:nvSpPr>
+        <p:spPr>
+          <a:xfrm>
+            <a:off x="502920" y="530352"/>
+            <a:ext cx="8138160" cy="685800"/>
+          </a:xfrm>
+          <a:prstGeom prst="rect">
+            <a:avLst/>
+          </a:prstGeom>
+          <a:noFill/>
+          <a:ln/>
+        </p:spPr>
+        <p:txBody>
+          <a:bodyPr wrap="square" lIns="0" tIns="0" rIns="0" bIns="0" rtlCol="0" anchor="ctr"/>
+          <a:lstStyle/>
+          <a:p>
+            <a:pPr marL="0" indent="0">
+              <a:buNone/>
+            </a:pPr>
+            <a:r>
+              <a:rPr lang="en-US" sz="3000" b="1" dirty="0">
+                <a:solidFill>
+                  <a:srgbClr val="1E2761"/>
+                </a:solidFill>
+                <a:latin typeface="Cambria" pitchFamily="34" charset="0"/>
+                <a:ea typeface="Cambria" pitchFamily="34" charset="-122"/>
+                <a:cs typeface="Cambria" pitchFamily="34" charset="-120"/>
+              </a:rPr>
+              <a:t>Incumbent vs. candidate: evidence before promotion</a:t>
+            </a:r>
+            <a:endParaRPr lang="en-US" sz="3000" dirty="0"/>
+          </a:p>
+        </p:txBody>
+      </p:sp>
+      <p:sp>
+        <p:nvSpPr>
+          <p:cNvPr id="4" name="Shape 2"/>
+          <p:cNvSpPr/>
+          <p:nvPr/>
+        </p:nvSpPr>
+        <p:spPr>
+          <a:xfrm>
+            <a:off x="548640" y="1371600"/>
+            <a:ext cx="457200" cy="457200"/>
+          </a:xfrm>
+          <a:prstGeom prst="ellipse">
+            <a:avLst/>
+          </a:prstGeom>
+          <a:solidFill>
+            <a:srgbClr val="1E2761"/>
+          </a:solidFill>
+          <a:ln/>
+        </p:spPr>
+        <p:txBody>
+          <a:bodyPr/>
+          <a:lstStyle/>
+          <a:p>
+            <a:endParaRPr lang="en-GB"/>
+          </a:p>
+        </p:txBody>
+      </p:sp>
+      <p:sp>
+        <p:nvSpPr>
+          <p:cNvPr id="6" name="Text 3"/>
+          <p:cNvSpPr/>
+          <p:nvPr/>
+        </p:nvSpPr>
+        <p:spPr>
+          <a:xfrm>
+            <a:off x="1188720" y="1380744"/>
+            <a:ext cx="1828800" cy="411480"/>
+          </a:xfrm>
+          <a:prstGeom prst="rect">
+            <a:avLst/>
+          </a:prstGeom>
+          <a:noFill/>
+          <a:ln/>
+        </p:spPr>
+        <p:txBody>
+          <a:bodyPr wrap="square" lIns="0" tIns="0" rIns="0" bIns="0" rtlCol="0" anchor="ctr"/>
+          <a:lstStyle/>
+          <a:p>
+            <a:pPr marL="0" indent="0">
+              <a:buNone/>
+            </a:pPr>
+            <a:r>
+              <a:rPr lang="en-US" sz="1350" b="1" dirty="0">
+                <a:solidFill>
+                  <a:srgbClr val="1E2761"/>
+                </a:solidFill>
+                <a:latin typeface="Calibri" pitchFamily="34" charset="0"/>
+                <a:ea typeface="Calibri" pitchFamily="34" charset="-122"/>
+                <a:cs typeface="Calibri" pitchFamily="34" charset="-120"/>
+              </a:rPr>
+              <a:t>1. Version</a:t>
+            </a:r>
+            <a:endParaRPr lang="en-US" sz="1350" dirty="0"/>
+          </a:p>
+        </p:txBody>
+      </p:sp>
+      <p:sp>
+        <p:nvSpPr>
+          <p:cNvPr id="7" name="Text 4"/>
+          <p:cNvSpPr/>
+          <p:nvPr/>
+        </p:nvSpPr>
+        <p:spPr>
+          <a:xfrm>
+            <a:off x="3063240" y="1344168"/>
+            <a:ext cx="5577840" cy="658368"/>
+          </a:xfrm>
+          <a:prstGeom prst="rect">
+            <a:avLst/>
+          </a:prstGeom>
+          <a:noFill/>
+          <a:ln/>
+        </p:spPr>
+        <p:txBody>
+          <a:bodyPr wrap="square" lIns="0" tIns="0" rIns="0" bIns="0" rtlCol="0" anchor="ctr"/>
+          <a:lstStyle/>
+          <a:p>
+            <a:pPr marL="0" indent="0">
+              <a:buNone/>
+            </a:pPr>
+            <a:r>
+              <a:rPr lang="en-US" sz="1050" dirty="0">
+                <a:solidFill>
+                  <a:srgbClr val="20263F"/>
+                </a:solidFill>
+                <a:latin typeface="Calibri" pitchFamily="34" charset="0"/>
+                <a:ea typeface="Calibri" pitchFamily="34" charset="-122"/>
+                <a:cs typeface="Calibri" pitchFamily="34" charset="-120"/>
+              </a:rPr>
+              <a:t>Create two versions under one agent name — different model deployments, or a clearly labelled prompt rehearsal.</a:t>
+            </a:r>
+            <a:endParaRPr lang="en-US" sz="1050" dirty="0"/>
+          </a:p>
+        </p:txBody>
+      </p:sp>
+      <p:sp>
+        <p:nvSpPr>
+          <p:cNvPr id="8" name="Shape 5"/>
+          <p:cNvSpPr/>
+          <p:nvPr/>
+        </p:nvSpPr>
+        <p:spPr>
+          <a:xfrm>
+            <a:off x="548640" y="2066544"/>
+            <a:ext cx="457200" cy="457200"/>
+          </a:xfrm>
+          <a:prstGeom prst="ellipse">
+            <a:avLst/>
+          </a:prstGeom>
+          <a:solidFill>
+            <a:srgbClr val="1E2761"/>
+          </a:solidFill>
+          <a:ln/>
+        </p:spPr>
+        <p:txBody>
+          <a:bodyPr/>
+          <a:lstStyle/>
+          <a:p>
+            <a:endParaRPr lang="en-GB"/>
+          </a:p>
+        </p:txBody>
+      </p:sp>
+      <p:sp>
+        <p:nvSpPr>
+          <p:cNvPr id="10" name="Text 6"/>
+          <p:cNvSpPr/>
+          <p:nvPr/>
+        </p:nvSpPr>
+        <p:spPr>
+          <a:xfrm>
+            <a:off x="1188720" y="2075688"/>
+            <a:ext cx="1828800" cy="411480"/>
+          </a:xfrm>
+          <a:prstGeom prst="rect">
+            <a:avLst/>
+          </a:prstGeom>
+          <a:noFill/>
+          <a:ln/>
+        </p:spPr>
+        <p:txBody>
+          <a:bodyPr wrap="square" lIns="0" tIns="0" rIns="0" bIns="0" rtlCol="0" anchor="ctr"/>
+          <a:lstStyle/>
+          <a:p>
+            <a:pPr marL="0" indent="0">
+              <a:buNone/>
+            </a:pPr>
+            <a:r>
+              <a:rPr lang="en-US" sz="1350" b="1" dirty="0">
+                <a:solidFill>
+                  <a:srgbClr val="1E2761"/>
+                </a:solidFill>
+                <a:latin typeface="Calibri" pitchFamily="34" charset="0"/>
+                <a:ea typeface="Calibri" pitchFamily="34" charset="-122"/>
+                <a:cs typeface="Calibri" pitchFamily="34" charset="-120"/>
+              </a:rPr>
+              <a:t>2. Execute</a:t>
+            </a:r>
+            <a:endParaRPr lang="en-US" sz="1350" dirty="0"/>
+          </a:p>
+        </p:txBody>
+      </p:sp>
+      <p:sp>
+        <p:nvSpPr>
+          <p:cNvPr id="11" name="Text 7"/>
+          <p:cNvSpPr/>
+          <p:nvPr/>
+        </p:nvSpPr>
+        <p:spPr>
+          <a:xfrm>
+            <a:off x="3063240" y="2039112"/>
+            <a:ext cx="5577840" cy="658368"/>
+          </a:xfrm>
+          <a:prstGeom prst="rect">
+            <a:avLst/>
+          </a:prstGeom>
+          <a:noFill/>
+          <a:ln/>
+        </p:spPr>
+        <p:txBody>
+          <a:bodyPr wrap="square" lIns="0" tIns="0" rIns="0" bIns="0" rtlCol="0" anchor="ctr"/>
+          <a:lstStyle/>
+          <a:p>
+            <a:pPr marL="0" indent="0">
+              <a:buNone/>
+            </a:pPr>
+            <a:r>
+              <a:rPr lang="en-US" sz="1050" dirty="0">
+                <a:solidFill>
+                  <a:srgbClr val="20263F"/>
+                </a:solidFill>
+                <a:latin typeface="Calibri" pitchFamily="34" charset="0"/>
+                <a:ea typeface="Calibri" pitchFamily="34" charset="-122"/>
+                <a:cs typeface="Calibri" pitchFamily="34" charset="-120"/>
+              </a:rPr>
+              <a:t>Run both versions against the same reviewed dataset; preserve stable case IDs and generated response lineage.</a:t>
+            </a:r>
+            <a:endParaRPr lang="en-US" sz="1050" dirty="0"/>
+          </a:p>
+        </p:txBody>
+      </p:sp>
+      <p:sp>
+        <p:nvSpPr>
+          <p:cNvPr id="12" name="Shape 8"/>
+          <p:cNvSpPr/>
+          <p:nvPr/>
+        </p:nvSpPr>
+        <p:spPr>
+          <a:xfrm>
+            <a:off x="548640" y="2761488"/>
+            <a:ext cx="457200" cy="457200"/>
+          </a:xfrm>
+          <a:prstGeom prst="ellipse">
+            <a:avLst/>
+          </a:prstGeom>
+          <a:solidFill>
+            <a:srgbClr val="1E2761"/>
+          </a:solidFill>
+          <a:ln/>
+        </p:spPr>
+        <p:txBody>
+          <a:bodyPr/>
+          <a:lstStyle/>
+          <a:p>
+            <a:endParaRPr lang="en-GB"/>
+          </a:p>
+        </p:txBody>
+      </p:sp>
+      <p:sp>
+        <p:nvSpPr>
+          <p:cNvPr id="14" name="Text 9"/>
+          <p:cNvSpPr/>
+          <p:nvPr/>
+        </p:nvSpPr>
+        <p:spPr>
+          <a:xfrm>
+            <a:off x="1188720" y="2770632"/>
+            <a:ext cx="1828800" cy="411480"/>
+          </a:xfrm>
+          <a:prstGeom prst="rect">
+            <a:avLst/>
+          </a:prstGeom>
+          <a:noFill/>
+          <a:ln/>
+        </p:spPr>
+        <p:txBody>
+          <a:bodyPr wrap="square" lIns="0" tIns="0" rIns="0" bIns="0" rtlCol="0" anchor="ctr"/>
+          <a:lstStyle/>
+          <a:p>
+            <a:pPr marL="0" indent="0">
+              <a:buNone/>
+            </a:pPr>
+            <a:r>
+              <a:rPr lang="en-US" sz="1350" b="1" dirty="0">
+                <a:solidFill>
+                  <a:srgbClr val="1E2761"/>
+                </a:solidFill>
+                <a:latin typeface="Calibri" pitchFamily="34" charset="0"/>
+                <a:ea typeface="Calibri" pitchFamily="34" charset="-122"/>
+                <a:cs typeface="Calibri" pitchFamily="34" charset="-120"/>
+              </a:rPr>
+              <a:t>3. Contract</a:t>
+            </a:r>
+            <a:endParaRPr lang="en-US" sz="1350" dirty="0"/>
+          </a:p>
+        </p:txBody>
+      </p:sp>
+      <p:sp>
+        <p:nvSpPr>
+          <p:cNvPr id="15" name="Text 10"/>
+          <p:cNvSpPr/>
+          <p:nvPr/>
+        </p:nvSpPr>
+        <p:spPr>
+          <a:xfrm>
+            <a:off x="3063240" y="2734056"/>
+            <a:ext cx="5577840" cy="658368"/>
+          </a:xfrm>
+          <a:prstGeom prst="rect">
+            <a:avLst/>
+          </a:prstGeom>
+          <a:noFill/>
+          <a:ln/>
+        </p:spPr>
+        <p:txBody>
+          <a:bodyPr wrap="square" lIns="0" tIns="0" rIns="0" bIns="0" rtlCol="0" anchor="ctr"/>
+          <a:lstStyle/>
+          <a:p>
+            <a:pPr marL="0" indent="0">
+              <a:buNone/>
+            </a:pPr>
+            <a:r>
+              <a:rPr lang="en-US" sz="1050" dirty="0">
+                <a:solidFill>
+                  <a:srgbClr val="20263F"/>
+                </a:solidFill>
+                <a:latin typeface="Calibri" pitchFamily="34" charset="0"/>
+                <a:ea typeface="Calibri" pitchFamily="34" charset="-122"/>
+                <a:cs typeface="Calibri" pitchFamily="34" charset="-120"/>
+              </a:rPr>
+              <a:t>check_contracts.py must pass for tool names, arguments, schemas, expected calls, and no-tool cohorts.</a:t>
+            </a:r>
+            <a:endParaRPr lang="en-US" sz="1050" dirty="0"/>
+          </a:p>
+        </p:txBody>
+      </p:sp>
+      <p:sp>
+        <p:nvSpPr>
+          <p:cNvPr id="16" name="Shape 11"/>
+          <p:cNvSpPr/>
+          <p:nvPr/>
+        </p:nvSpPr>
+        <p:spPr>
+          <a:xfrm>
+            <a:off x="548640" y="3456432"/>
+            <a:ext cx="457200" cy="457200"/>
+          </a:xfrm>
+          <a:prstGeom prst="ellipse">
+            <a:avLst/>
+          </a:prstGeom>
+          <a:solidFill>
+            <a:srgbClr val="1E2761"/>
+          </a:solidFill>
+          <a:ln/>
+        </p:spPr>
+        <p:txBody>
+          <a:bodyPr/>
+          <a:lstStyle/>
+          <a:p>
+            <a:endParaRPr lang="en-GB"/>
+          </a:p>
+        </p:txBody>
+      </p:sp>
+      <p:sp>
+        <p:nvSpPr>
+          <p:cNvPr id="18" name="Text 12"/>
+          <p:cNvSpPr/>
+          <p:nvPr/>
+        </p:nvSpPr>
+        <p:spPr>
+          <a:xfrm>
+            <a:off x="1188720" y="3465576"/>
+            <a:ext cx="1828800" cy="411480"/>
+          </a:xfrm>
+          <a:prstGeom prst="rect">
+            <a:avLst/>
+          </a:prstGeom>
+          <a:noFill/>
+          <a:ln/>
+        </p:spPr>
+        <p:txBody>
+          <a:bodyPr wrap="square" lIns="0" tIns="0" rIns="0" bIns="0" rtlCol="0" anchor="ctr"/>
+          <a:lstStyle/>
+          <a:p>
+            <a:pPr marL="0" indent="0">
+              <a:buNone/>
+            </a:pPr>
+            <a:r>
+              <a:rPr lang="en-US" sz="1350" b="1" dirty="0">
+                <a:solidFill>
+                  <a:srgbClr val="1E2761"/>
+                </a:solidFill>
+                <a:latin typeface="Calibri" pitchFamily="34" charset="0"/>
+                <a:ea typeface="Calibri" pitchFamily="34" charset="-122"/>
+                <a:cs typeface="Calibri" pitchFamily="34" charset="-120"/>
+              </a:rPr>
+              <a:t>4. Compare</a:t>
+            </a:r>
+            <a:endParaRPr lang="en-US" sz="1350" dirty="0"/>
+          </a:p>
+        </p:txBody>
+      </p:sp>
+      <p:sp>
+        <p:nvSpPr>
+          <p:cNvPr id="19" name="Text 13"/>
+          <p:cNvSpPr/>
+          <p:nvPr/>
+        </p:nvSpPr>
+        <p:spPr>
+          <a:xfrm>
+            <a:off x="3063240" y="3429000"/>
+            <a:ext cx="5577840" cy="658368"/>
+          </a:xfrm>
+          <a:prstGeom prst="rect">
+            <a:avLst/>
+          </a:prstGeom>
+          <a:noFill/>
+          <a:ln/>
+        </p:spPr>
+        <p:txBody>
+          <a:bodyPr wrap="square" lIns="0" tIns="0" rIns="0" bIns="0" rtlCol="0" anchor="ctr"/>
+          <a:lstStyle/>
+          <a:p>
+            <a:pPr marL="0" indent="0">
+              <a:buNone/>
+            </a:pPr>
+            <a:r>
+              <a:rPr lang="en-US" sz="1050" dirty="0">
+                <a:solidFill>
+                  <a:srgbClr val="20263F"/>
+                </a:solidFill>
+                <a:latin typeface="Calibri" pitchFamily="34" charset="0"/>
+                <a:ea typeface="Calibri" pitchFamily="34" charset="-122"/>
+                <a:cs typeface="Calibri" pitchFamily="34" charset="-120"/>
+              </a:rPr>
+              <a:t>Score both runs in one Foundry evaluation group; inspect confidence intervals, pairwise results, and regressed rows.</a:t>
+            </a:r>
+            <a:endParaRPr lang="en-US" sz="1050" dirty="0"/>
+          </a:p>
+        </p:txBody>
+      </p:sp>
+      <p:sp>
+        <p:nvSpPr>
+          <p:cNvPr id="20" name="Shape 14"/>
+          <p:cNvSpPr/>
+          <p:nvPr/>
+        </p:nvSpPr>
+        <p:spPr>
+          <a:xfrm>
+            <a:off x="548640" y="4151376"/>
+            <a:ext cx="457200" cy="457200"/>
+          </a:xfrm>
+          <a:prstGeom prst="ellipse">
+            <a:avLst/>
+          </a:prstGeom>
+          <a:solidFill>
+            <a:srgbClr val="1E2761"/>
+          </a:solidFill>
+          <a:ln/>
+        </p:spPr>
+        <p:txBody>
+          <a:bodyPr/>
+          <a:lstStyle/>
+          <a:p>
+            <a:endParaRPr lang="en-GB"/>
+          </a:p>
+        </p:txBody>
+      </p:sp>
+      <p:sp>
+        <p:nvSpPr>
+          <p:cNvPr id="22" name="Text 15"/>
+          <p:cNvSpPr/>
+          <p:nvPr/>
+        </p:nvSpPr>
+        <p:spPr>
+          <a:xfrm>
+            <a:off x="1188720" y="4160520"/>
+            <a:ext cx="1828800" cy="411480"/>
+          </a:xfrm>
+          <a:prstGeom prst="rect">
+            <a:avLst/>
+          </a:prstGeom>
+          <a:noFill/>
+          <a:ln/>
+        </p:spPr>
+        <p:txBody>
+          <a:bodyPr wrap="square" lIns="0" tIns="0" rIns="0" bIns="0" rtlCol="0" anchor="ctr"/>
+          <a:lstStyle/>
+          <a:p>
+            <a:pPr marL="0" indent="0">
+              <a:buNone/>
+            </a:pPr>
+            <a:r>
+              <a:rPr lang="en-US" sz="1350" b="1" dirty="0">
+                <a:solidFill>
+                  <a:srgbClr val="1E2761"/>
+                </a:solidFill>
+                <a:latin typeface="Calibri" pitchFamily="34" charset="0"/>
+                <a:ea typeface="Calibri" pitchFamily="34" charset="-122"/>
+                <a:cs typeface="Calibri" pitchFamily="34" charset="-120"/>
+              </a:rPr>
+              <a:t>5. Decide</a:t>
+            </a:r>
+            <a:endParaRPr lang="en-US" sz="1350" dirty="0"/>
+          </a:p>
+        </p:txBody>
+      </p:sp>
+      <p:sp>
+        <p:nvSpPr>
+          <p:cNvPr id="23" name="Text 16"/>
+          <p:cNvSpPr/>
+          <p:nvPr/>
+        </p:nvSpPr>
+        <p:spPr>
+          <a:xfrm>
+            <a:off x="3063240" y="4123944"/>
+            <a:ext cx="5577840" cy="658368"/>
+          </a:xfrm>
+          <a:prstGeom prst="rect">
+            <a:avLst/>
+          </a:prstGeom>
+          <a:noFill/>
+          <a:ln/>
+        </p:spPr>
+        <p:txBody>
+          <a:bodyPr wrap="square" lIns="0" tIns="0" rIns="0" bIns="0" rtlCol="0" anchor="ctr"/>
+          <a:lstStyle/>
+          <a:p>
+            <a:pPr marL="0" indent="0">
+              <a:buNone/>
+            </a:pPr>
+            <a:r>
+              <a:rPr lang="en-US" sz="1050" dirty="0">
+                <a:solidFill>
+                  <a:srgbClr val="20263F"/>
+                </a:solidFill>
+                <a:latin typeface="Calibri" pitchFamily="34" charset="0"/>
+                <a:ea typeface="Calibri" pitchFamily="34" charset="-122"/>
+                <a:cs typeface="Calibri" pitchFamily="34" charset="-120"/>
+              </a:rPr>
+              <a:t>eval_gate.py enforces safety, quality, cohort, and provenance policy. Promotion remains manual and reviewed.</a:t>
+            </a:r>
+            <a:endParaRPr lang="en-US" sz="1050" dirty="0"/>
+          </a:p>
+        </p:txBody>
+      </p:sp>
+      <p:pic>
+        <p:nvPicPr>
+          <p:cNvPr id="24" name="Picture 23" descr="image.png"/>
+          <p:cNvPicPr>
+            <a:picLocks noChangeAspect="1"/>
+          </p:cNvPicPr>
+          <p:nvPr/>
+        </p:nvPicPr>
+        <p:blipFill>
+          <a:blip r:embed="rId3"/>
+          <a:stretch>
+            <a:fillRect/>
+          </a:stretch>
+        </p:blipFill>
+        <p:spPr>
+          <a:xfrm>
+            <a:off x="667512" y="1490472"/>
+            <a:ext cx="219456" cy="219456"/>
+          </a:xfrm>
+          <a:prstGeom prst="rect">
+            <a:avLst/>
+          </a:prstGeom>
+        </p:spPr>
+      </p:pic>
+      <p:pic>
+        <p:nvPicPr>
+          <p:cNvPr id="25" name="Picture 24" descr="image.png"/>
+          <p:cNvPicPr>
+            <a:picLocks noChangeAspect="1"/>
+          </p:cNvPicPr>
+          <p:nvPr/>
+        </p:nvPicPr>
+        <p:blipFill>
+          <a:blip r:embed="rId4"/>
+          <a:stretch>
+            <a:fillRect/>
+          </a:stretch>
+        </p:blipFill>
+        <p:spPr>
+          <a:xfrm>
+            <a:off x="667512" y="2185416"/>
+            <a:ext cx="219456" cy="219456"/>
+          </a:xfrm>
+          <a:prstGeom prst="rect">
+            <a:avLst/>
+          </a:prstGeom>
+        </p:spPr>
+      </p:pic>
+      <p:pic>
+        <p:nvPicPr>
+          <p:cNvPr id="26" name="Picture 25" descr="image.png"/>
+          <p:cNvPicPr>
+            <a:picLocks noChangeAspect="1"/>
+          </p:cNvPicPr>
+          <p:nvPr/>
+        </p:nvPicPr>
+        <p:blipFill>
+          <a:blip r:embed="rId5"/>
+          <a:stretch>
+            <a:fillRect/>
+          </a:stretch>
+        </p:blipFill>
+        <p:spPr>
+          <a:xfrm>
+            <a:off x="667512" y="2880360"/>
+            <a:ext cx="219456" cy="219456"/>
+          </a:xfrm>
+          <a:prstGeom prst="rect">
+            <a:avLst/>
+          </a:prstGeom>
+        </p:spPr>
+      </p:pic>
+      <p:pic>
+        <p:nvPicPr>
+          <p:cNvPr id="27" name="Picture 26" descr="image.png"/>
+          <p:cNvPicPr>
+            <a:picLocks noChangeAspect="1"/>
+          </p:cNvPicPr>
+          <p:nvPr/>
+        </p:nvPicPr>
+        <p:blipFill>
+          <a:blip r:embed="rId6"/>
+          <a:stretch>
+            <a:fillRect/>
+          </a:stretch>
+        </p:blipFill>
+        <p:spPr>
+          <a:xfrm>
+            <a:off x="667512" y="3575304"/>
+            <a:ext cx="219456" cy="219456"/>
+          </a:xfrm>
+          <a:prstGeom prst="rect">
+            <a:avLst/>
+          </a:prstGeom>
+        </p:spPr>
+      </p:pic>
+      <p:pic>
+        <p:nvPicPr>
+          <p:cNvPr id="28" name="Picture 27" descr="image.png"/>
+          <p:cNvPicPr>
+            <a:picLocks noChangeAspect="1"/>
+          </p:cNvPicPr>
+          <p:nvPr/>
+        </p:nvPicPr>
+        <p:blipFill>
+          <a:blip r:embed="rId7"/>
+          <a:stretch>
+            <a:fillRect/>
+          </a:stretch>
+        </p:blipFill>
+        <p:spPr>
+          <a:xfrm>
+            <a:off x="667512" y="4270248"/>
+            <a:ext cx="219456" cy="219456"/>
+          </a:xfrm>
+          <a:prstGeom prst="rect">
+            <a:avLst/>
+          </a:prstGeom>
+        </p:spPr>
+      </p:pic>
+    </p:spTree>
+  </p:cSld>
+  <p:clrMapOvr>
+    <a:masterClrMapping/>
+  </p:clrMapOvr>
+</p:sld>
+</file>
+
+<file path=ppt/slides/slide17.xml><?xml version="1.0" encoding="utf-8"?>
 <p:sld xmlns:a="http://schemas.openxmlformats.org/drawingml/2006/main" xmlns:r="http://schemas.openxmlformats.org/officeDocument/2006/relationships" xmlns:p="http://schemas.openxmlformats.org/presentationml/2006/main">
   <p:cSld name="Slide 16">
     <p:bg>
@@ -6655,7 +7441,7 @@
 </p:sld>
 </file>
 
-<file path=ppt/slides/slide17.xml><?xml version="1.0" encoding="utf-8"?>
+<file path=ppt/slides/slide18.xml><?xml version="1.0" encoding="utf-8"?>
 <p:sld xmlns:a="http://schemas.openxmlformats.org/drawingml/2006/main" xmlns:r="http://schemas.openxmlformats.org/officeDocument/2006/relationships" xmlns:p="http://schemas.openxmlformats.org/presentationml/2006/main">
   <p:cSld name="Slide 17">
     <p:bg>
@@ -7411,7 +8197,7 @@
 </p:sld>
 </file>
 
-<file path=ppt/slides/slide18.xml><?xml version="1.0" encoding="utf-8"?>
+<file path=ppt/slides/slide19.xml><?xml version="1.0" encoding="utf-8"?>
 <p:sld xmlns:a="http://schemas.openxmlformats.org/drawingml/2006/main" xmlns:r="http://schemas.openxmlformats.org/officeDocument/2006/relationships" xmlns:p="http://schemas.openxmlformats.org/presentationml/2006/main">
   <p:cSld name="Slide 18">
     <p:bg>
@@ -8159,554 +8945,6 @@
               <a:t>An unreviewed synthetic dataset is a draft — never validation evidence.</a:t>
             </a:r>
             <a:endParaRPr lang="en-US" sz="1300" dirty="0"/>
-          </a:p>
-        </p:txBody>
-      </p:sp>
-    </p:spTree>
-  </p:cSld>
-  <p:clrMapOvr>
-    <a:masterClrMapping/>
-  </p:clrMapOvr>
-</p:sld>
-</file>
-
-<file path=ppt/slides/slide19.xml><?xml version="1.0" encoding="utf-8"?>
-<p:sld xmlns:a="http://schemas.openxmlformats.org/drawingml/2006/main" xmlns:r="http://schemas.openxmlformats.org/officeDocument/2006/relationships" xmlns:p="http://schemas.openxmlformats.org/presentationml/2006/main">
-  <p:cSld name="Slide 19">
-    <p:bg>
-      <p:bgPr>
-        <a:solidFill>
-          <a:srgbClr val="FFFFFF"/>
-        </a:solidFill>
-        <a:effectLst/>
-      </p:bgPr>
-    </p:bg>
-    <p:spTree>
-      <p:nvGrpSpPr>
-        <p:cNvPr id="1" name=""/>
-        <p:cNvGrpSpPr/>
-        <p:nvPr/>
-      </p:nvGrpSpPr>
-      <p:grpSpPr>
-        <a:xfrm>
-          <a:off x="0" y="0"/>
-          <a:ext cx="0" cy="0"/>
-          <a:chOff x="0" y="0"/>
-          <a:chExt cx="0" cy="0"/>
-        </a:xfrm>
-      </p:grpSpPr>
-      <p:sp>
-        <p:nvSpPr>
-          <p:cNvPr id="2" name="Text 0"/>
-          <p:cNvSpPr/>
-          <p:nvPr/>
-        </p:nvSpPr>
-        <p:spPr>
-          <a:xfrm>
-            <a:off x="502920" y="274320"/>
-            <a:ext cx="8138160" cy="274320"/>
-          </a:xfrm>
-          <a:prstGeom prst="rect">
-            <a:avLst/>
-          </a:prstGeom>
-          <a:noFill/>
-          <a:ln/>
-        </p:spPr>
-        <p:txBody>
-          <a:bodyPr wrap="square" lIns="0" tIns="0" rIns="0" bIns="0" rtlCol="0" anchor="ctr"/>
-          <a:lstStyle/>
-          <a:p>
-            <a:pPr marL="0" indent="0">
-              <a:buNone/>
-            </a:pPr>
-            <a:r>
-              <a:rPr lang="en-US" sz="1100" b="1" kern="0" spc="300" dirty="0">
-                <a:solidFill>
-                  <a:srgbClr val="5A6378"/>
-                </a:solidFill>
-                <a:latin typeface="Calibri" pitchFamily="34" charset="0"/>
-                <a:ea typeface="Calibri" pitchFamily="34" charset="-122"/>
-                <a:cs typeface="Calibri" pitchFamily="34" charset="-120"/>
-              </a:rPr>
-              <a:t>GXP VARIANT · SCENARIO &amp; LIMITS</a:t>
-            </a:r>
-            <a:endParaRPr lang="en-US" sz="1100" dirty="0"/>
-          </a:p>
-        </p:txBody>
-      </p:sp>
-      <p:sp>
-        <p:nvSpPr>
-          <p:cNvPr id="3" name="Text 1"/>
-          <p:cNvSpPr/>
-          <p:nvPr/>
-        </p:nvSpPr>
-        <p:spPr>
-          <a:xfrm>
-            <a:off x="502920" y="530352"/>
-            <a:ext cx="8138160" cy="685800"/>
-          </a:xfrm>
-          <a:prstGeom prst="rect">
-            <a:avLst/>
-          </a:prstGeom>
-          <a:noFill/>
-          <a:ln/>
-        </p:spPr>
-        <p:txBody>
-          <a:bodyPr wrap="square" lIns="0" tIns="0" rIns="0" bIns="0" rtlCol="0" anchor="ctr"/>
-          <a:lstStyle/>
-          <a:p>
-            <a:pPr marL="0" indent="0">
-              <a:buNone/>
-            </a:pPr>
-            <a:r>
-              <a:rPr lang="en-US" sz="3000" b="1" dirty="0">
-                <a:solidFill>
-                  <a:srgbClr val="1E2761"/>
-                </a:solidFill>
-                <a:latin typeface="Cambria" pitchFamily="34" charset="0"/>
-                <a:ea typeface="Cambria" pitchFamily="34" charset="-122"/>
-                <a:cs typeface="Cambria" pitchFamily="34" charset="-120"/>
-              </a:rPr>
-              <a:t>The GxP lab: refusals are the main event</a:t>
-            </a:r>
-            <a:endParaRPr lang="en-US" sz="3000" dirty="0"/>
-          </a:p>
-        </p:txBody>
-      </p:sp>
-      <p:sp>
-        <p:nvSpPr>
-          <p:cNvPr id="4" name="Shape 2"/>
-          <p:cNvSpPr/>
-          <p:nvPr/>
-        </p:nvSpPr>
-        <p:spPr>
-          <a:xfrm>
-            <a:off x="502920" y="1417320"/>
-            <a:ext cx="3950208" cy="3246120"/>
-          </a:xfrm>
-          <a:prstGeom prst="roundRect">
-            <a:avLst>
-              <a:gd name="adj" fmla="val 1690"/>
-            </a:avLst>
-          </a:prstGeom>
-          <a:solidFill>
-            <a:srgbClr val="EEF4FE"/>
-          </a:solidFill>
-          <a:ln/>
-          <a:effectLst>
-            <a:outerShdw blurRad="88900" dist="25400" dir="2700000" algn="bl" rotWithShape="0">
-              <a:srgbClr val="000000">
-                <a:alpha val="14000"/>
-              </a:srgbClr>
-            </a:outerShdw>
-          </a:effectLst>
-        </p:spPr>
-        <p:txBody>
-          <a:bodyPr/>
-          <a:lstStyle/>
-          <a:p>
-            <a:endParaRPr lang="en-GB"/>
-          </a:p>
-        </p:txBody>
-      </p:sp>
-      <p:sp>
-        <p:nvSpPr>
-          <p:cNvPr id="5" name="Shape 3"/>
-          <p:cNvSpPr/>
-          <p:nvPr/>
-        </p:nvSpPr>
-        <p:spPr>
-          <a:xfrm>
-            <a:off x="685800" y="1600200"/>
-            <a:ext cx="457200" cy="457200"/>
-          </a:xfrm>
-          <a:prstGeom prst="ellipse">
-            <a:avLst/>
-          </a:prstGeom>
-          <a:solidFill>
-            <a:srgbClr val="1E2761"/>
-          </a:solidFill>
-          <a:ln/>
-        </p:spPr>
-        <p:txBody>
-          <a:bodyPr/>
-          <a:lstStyle/>
-          <a:p>
-            <a:endParaRPr lang="en-GB"/>
-          </a:p>
-        </p:txBody>
-      </p:sp>
-      <p:pic>
-        <p:nvPicPr>
-          <p:cNvPr id="6" name="Image 0" descr="preencoded.png"/>
-          <p:cNvPicPr>
-            <a:picLocks noChangeAspect="1"/>
-          </p:cNvPicPr>
-          <p:nvPr/>
-        </p:nvPicPr>
-        <p:blipFill>
-          <a:blip r:embed="rId3"/>
-          <a:stretch>
-            <a:fillRect/>
-          </a:stretch>
-        </p:blipFill>
-        <p:spPr>
-          <a:xfrm>
-            <a:off x="804672" y="1719072"/>
-            <a:ext cx="219456" cy="219456"/>
-          </a:xfrm>
-          <a:prstGeom prst="rect">
-            <a:avLst/>
-          </a:prstGeom>
-        </p:spPr>
-      </p:pic>
-      <p:sp>
-        <p:nvSpPr>
-          <p:cNvPr id="7" name="Text 4"/>
-          <p:cNvSpPr/>
-          <p:nvPr/>
-        </p:nvSpPr>
-        <p:spPr>
-          <a:xfrm>
-            <a:off x="1280160" y="1664208"/>
-            <a:ext cx="3063240" cy="365760"/>
-          </a:xfrm>
-          <a:prstGeom prst="rect">
-            <a:avLst/>
-          </a:prstGeom>
-          <a:noFill/>
-          <a:ln/>
-        </p:spPr>
-        <p:txBody>
-          <a:bodyPr wrap="square" lIns="0" tIns="0" rIns="0" bIns="0" rtlCol="0" anchor="ctr"/>
-          <a:lstStyle/>
-          <a:p>
-            <a:pPr marL="0" indent="0">
-              <a:buNone/>
-            </a:pPr>
-            <a:r>
-              <a:rPr lang="en-US" sz="1350" b="1" dirty="0">
-                <a:solidFill>
-                  <a:srgbClr val="1E2761"/>
-                </a:solidFill>
-                <a:latin typeface="Calibri" pitchFamily="34" charset="0"/>
-                <a:ea typeface="Calibri" pitchFamily="34" charset="-122"/>
-                <a:cs typeface="Calibri" pitchFamily="34" charset="-120"/>
-              </a:rPr>
-              <a:t>SOP &amp; deviation-triage assistant</a:t>
-            </a:r>
-            <a:endParaRPr lang="en-US" sz="1350" dirty="0"/>
-          </a:p>
-        </p:txBody>
-      </p:sp>
-      <p:sp>
-        <p:nvSpPr>
-          <p:cNvPr id="8" name="Text 5"/>
-          <p:cNvSpPr/>
-          <p:nvPr/>
-        </p:nvSpPr>
-        <p:spPr>
-          <a:xfrm>
-            <a:off x="731520" y="2194560"/>
-            <a:ext cx="3520440" cy="2377440"/>
-          </a:xfrm>
-          <a:prstGeom prst="rect">
-            <a:avLst/>
-          </a:prstGeom>
-          <a:noFill/>
-          <a:ln/>
-        </p:spPr>
-        <p:txBody>
-          <a:bodyPr wrap="square" rtlCol="0" anchor="ctr"/>
-          <a:lstStyle/>
-          <a:p>
-            <a:pPr marL="342900" indent="-342900">
-              <a:spcAft>
-                <a:spcPts val="600"/>
-              </a:spcAft>
-              <a:buSzPct val="100000"/>
-              <a:buChar char="•"/>
-            </a:pPr>
-            <a:r>
-              <a:rPr lang="en-US" sz="1100" dirty="0">
-                <a:solidFill>
-                  <a:srgbClr val="20263F"/>
-                </a:solidFill>
-                <a:latin typeface="Calibri" pitchFamily="34" charset="0"/>
-                <a:ea typeface="Calibri" pitchFamily="34" charset="-122"/>
-                <a:cs typeface="Calibri" pitchFamily="34" charset="-120"/>
-              </a:rPr>
-              <a:t>Answers SOP questions; helps classify deviations — must refuse release decisions, change approvals, and ALCOA+ violations · one of four discipline tracks (next slide)</a:t>
-            </a:r>
-            <a:endParaRPr lang="en-US" sz="1100" dirty="0"/>
-          </a:p>
-          <a:p>
-            <a:pPr marL="342900" indent="-342900">
-              <a:spcAft>
-                <a:spcPts val="600"/>
-              </a:spcAft>
-              <a:buSzPct val="100000"/>
-              <a:buChar char="•"/>
-            </a:pPr>
-            <a:r>
-              <a:rPr lang="en-US" sz="1100" dirty="0">
-                <a:solidFill>
-                  <a:srgbClr val="20263F"/>
-                </a:solidFill>
-                <a:latin typeface="Calibri" pitchFamily="34" charset="0"/>
-                <a:ea typeface="Calibri" pitchFamily="34" charset="-122"/>
-                <a:cs typeface="Calibri" pitchFamily="34" charset="-120"/>
-              </a:rPr>
-              <a:t>Data-integrity traps (“just backdate it”) are the core test — a failure here is a validation failure regardless of answer quality</a:t>
-            </a:r>
-            <a:endParaRPr lang="en-US" sz="1100" dirty="0"/>
-          </a:p>
-          <a:p>
-            <a:pPr marL="342900" indent="-342900">
-              <a:buSzPct val="100000"/>
-              <a:buChar char="•"/>
-            </a:pPr>
-            <a:r>
-              <a:rPr lang="en-US" sz="1100" dirty="0">
-                <a:solidFill>
-                  <a:srgbClr val="20263F"/>
-                </a:solidFill>
-                <a:latin typeface="Calibri" pitchFamily="34" charset="0"/>
-                <a:ea typeface="Calibri" pitchFamily="34" charset="-122"/>
-                <a:cs typeface="Calibri" pitchFamily="34" charset="-120"/>
-              </a:rPr>
-              <a:t>Evaluators: Task Adherence + Intent Resolution + Groundedness + a custom ALCOA+ adherence rubric (Module 3B exercise)</a:t>
-            </a:r>
-            <a:endParaRPr lang="en-US" sz="1100" dirty="0"/>
-          </a:p>
-        </p:txBody>
-      </p:sp>
-      <p:sp>
-        <p:nvSpPr>
-          <p:cNvPr id="9" name="Shape 6"/>
-          <p:cNvSpPr/>
-          <p:nvPr/>
-        </p:nvSpPr>
-        <p:spPr>
-          <a:xfrm>
-            <a:off x="4690872" y="1417320"/>
-            <a:ext cx="3950208" cy="3246120"/>
-          </a:xfrm>
-          <a:prstGeom prst="roundRect">
-            <a:avLst>
-              <a:gd name="adj" fmla="val 1690"/>
-            </a:avLst>
-          </a:prstGeom>
-          <a:solidFill>
-            <a:srgbClr val="1E2761"/>
-          </a:solidFill>
-          <a:ln/>
-          <a:effectLst>
-            <a:outerShdw blurRad="88900" dist="25400" dir="2700000" algn="bl" rotWithShape="0">
-              <a:srgbClr val="000000">
-                <a:alpha val="14000"/>
-              </a:srgbClr>
-            </a:outerShdw>
-          </a:effectLst>
-        </p:spPr>
-        <p:txBody>
-          <a:bodyPr/>
-          <a:lstStyle/>
-          <a:p>
-            <a:endParaRPr lang="en-GB"/>
-          </a:p>
-        </p:txBody>
-      </p:sp>
-      <p:sp>
-        <p:nvSpPr>
-          <p:cNvPr id="10" name="Shape 7"/>
-          <p:cNvSpPr/>
-          <p:nvPr/>
-        </p:nvSpPr>
-        <p:spPr>
-          <a:xfrm>
-            <a:off x="4873752" y="1600200"/>
-            <a:ext cx="457200" cy="457200"/>
-          </a:xfrm>
-          <a:prstGeom prst="ellipse">
-            <a:avLst/>
-          </a:prstGeom>
-          <a:solidFill>
-            <a:srgbClr val="D4544F"/>
-          </a:solidFill>
-          <a:ln/>
-        </p:spPr>
-        <p:txBody>
-          <a:bodyPr/>
-          <a:lstStyle/>
-          <a:p>
-            <a:endParaRPr lang="en-GB"/>
-          </a:p>
-        </p:txBody>
-      </p:sp>
-      <p:pic>
-        <p:nvPicPr>
-          <p:cNvPr id="11" name="Image 1" descr="preencoded.png"/>
-          <p:cNvPicPr>
-            <a:picLocks noChangeAspect="1"/>
-          </p:cNvPicPr>
-          <p:nvPr/>
-        </p:nvPicPr>
-        <p:blipFill>
-          <a:blip r:embed="rId4"/>
-          <a:stretch>
-            <a:fillRect/>
-          </a:stretch>
-        </p:blipFill>
-        <p:spPr>
-          <a:xfrm>
-            <a:off x="4992624" y="1719072"/>
-            <a:ext cx="219456" cy="219456"/>
-          </a:xfrm>
-          <a:prstGeom prst="rect">
-            <a:avLst/>
-          </a:prstGeom>
-        </p:spPr>
-      </p:pic>
-      <p:sp>
-        <p:nvSpPr>
-          <p:cNvPr id="12" name="Text 8"/>
-          <p:cNvSpPr/>
-          <p:nvPr/>
-        </p:nvSpPr>
-        <p:spPr>
-          <a:xfrm>
-            <a:off x="5468112" y="1664208"/>
-            <a:ext cx="3108960" cy="365760"/>
-          </a:xfrm>
-          <a:prstGeom prst="rect">
-            <a:avLst/>
-          </a:prstGeom>
-          <a:noFill/>
-          <a:ln/>
-        </p:spPr>
-        <p:txBody>
-          <a:bodyPr wrap="square" lIns="0" tIns="0" rIns="0" bIns="0" rtlCol="0" anchor="ctr"/>
-          <a:lstStyle/>
-          <a:p>
-            <a:pPr marL="0" indent="0">
-              <a:buNone/>
-            </a:pPr>
-            <a:r>
-              <a:rPr lang="en-US" sz="1350" b="1" dirty="0">
-                <a:solidFill>
-                  <a:srgbClr val="FFFFFF"/>
-                </a:solidFill>
-                <a:latin typeface="Calibri" pitchFamily="34" charset="0"/>
-                <a:ea typeface="Calibri" pitchFamily="34" charset="-122"/>
-                <a:cs typeface="Calibri" pitchFamily="34" charset="-120"/>
-              </a:rPr>
-              <a:t>What Foundry does NOT close</a:t>
-            </a:r>
-            <a:endParaRPr lang="en-US" sz="1350" dirty="0"/>
-          </a:p>
-        </p:txBody>
-      </p:sp>
-      <p:sp>
-        <p:nvSpPr>
-          <p:cNvPr id="13" name="Text 9"/>
-          <p:cNvSpPr/>
-          <p:nvPr/>
-        </p:nvSpPr>
-        <p:spPr>
-          <a:xfrm>
-            <a:off x="4919472" y="2194560"/>
-            <a:ext cx="3520440" cy="2377440"/>
-          </a:xfrm>
-          <a:prstGeom prst="rect">
-            <a:avLst/>
-          </a:prstGeom>
-          <a:noFill/>
-          <a:ln/>
-        </p:spPr>
-        <p:txBody>
-          <a:bodyPr wrap="square" rtlCol="0" anchor="ctr"/>
-          <a:lstStyle/>
-          <a:p>
-            <a:pPr marL="342900" indent="-342900">
-              <a:spcAft>
-                <a:spcPts val="600"/>
-              </a:spcAft>
-              <a:buSzPct val="100000"/>
-              <a:buChar char="•"/>
-            </a:pPr>
-            <a:r>
-              <a:rPr lang="en-US" sz="1100" dirty="0">
-                <a:solidFill>
-                  <a:srgbClr val="CADCFC"/>
-                </a:solidFill>
-                <a:latin typeface="Calibri" pitchFamily="34" charset="0"/>
-                <a:ea typeface="Calibri" pitchFamily="34" charset="-122"/>
-                <a:cs typeface="Calibri" pitchFamily="34" charset="-120"/>
-              </a:rPr>
-              <a:t>No such thing as “GxP-certified” tooling — validation responsibility stays yours under GAMP 5</a:t>
-            </a:r>
-            <a:endParaRPr lang="en-US" sz="1100" dirty="0"/>
-          </a:p>
-          <a:p>
-            <a:pPr marL="342900" indent="-342900">
-              <a:spcAft>
-                <a:spcPts val="600"/>
-              </a:spcAft>
-              <a:buSzPct val="100000"/>
-              <a:buChar char="•"/>
-            </a:pPr>
-            <a:r>
-              <a:rPr lang="en-US" sz="1100" dirty="0">
-                <a:solidFill>
-                  <a:srgbClr val="CADCFC"/>
-                </a:solidFill>
-                <a:latin typeface="Calibri" pitchFamily="34" charset="0"/>
-                <a:ea typeface="Calibri" pitchFamily="34" charset="-122"/>
-                <a:cs typeface="Calibri" pitchFamily="34" charset="-120"/>
-              </a:rPr>
-              <a:t>The judge model is validated software too: pin it, document it, re-baseline on change</a:t>
-            </a:r>
-            <a:endParaRPr lang="en-US" sz="1100" dirty="0"/>
-          </a:p>
-          <a:p>
-            <a:pPr marL="342900" indent="-342900">
-              <a:spcAft>
-                <a:spcPts val="600"/>
-              </a:spcAft>
-              <a:buSzPct val="100000"/>
-              <a:buChar char="•"/>
-            </a:pPr>
-            <a:r>
-              <a:rPr lang="en-US" sz="1100" dirty="0">
-                <a:solidFill>
-                  <a:srgbClr val="CADCFC"/>
-                </a:solidFill>
-                <a:latin typeface="Calibri" pitchFamily="34" charset="0"/>
-                <a:ea typeface="Calibri" pitchFamily="34" charset="-122"/>
-                <a:cs typeface="Calibri" pitchFamily="34" charset="-120"/>
-              </a:rPr>
-              <a:t>Retention &amp; tamper-evidence need explicit design against your Part 11 interpretation</a:t>
-            </a:r>
-            <a:endParaRPr lang="en-US" sz="1100" dirty="0"/>
-          </a:p>
-          <a:p>
-            <a:pPr marL="342900" indent="-342900">
-              <a:buSzPct val="100000"/>
-              <a:buChar char="•"/>
-            </a:pPr>
-            <a:r>
-              <a:rPr lang="en-US" sz="1100" dirty="0">
-                <a:solidFill>
-                  <a:srgbClr val="CADCFC"/>
-                </a:solidFill>
-                <a:latin typeface="Calibri" pitchFamily="34" charset="0"/>
-                <a:ea typeface="Calibri" pitchFamily="34" charset="-122"/>
-                <a:cs typeface="Calibri" pitchFamily="34" charset="-120"/>
-              </a:rPr>
-              <a:t>Human oversight is a process control (SOPs), not a product feature</a:t>
-            </a:r>
-            <a:endParaRPr lang="en-US" sz="1100" dirty="0"/>
           </a:p>
         </p:txBody>
       </p:sp>
@@ -9686,11 +9924,11 @@
 
 <file path=ppt/slides/slide20.xml><?xml version="1.0" encoding="utf-8"?>
 <p:sld xmlns:a="http://schemas.openxmlformats.org/drawingml/2006/main" xmlns:r="http://schemas.openxmlformats.org/officeDocument/2006/relationships" xmlns:p="http://schemas.openxmlformats.org/presentationml/2006/main">
-  <p:cSld name="Slide 20">
+  <p:cSld name="Slide 19">
     <p:bg>
       <p:bgPr>
         <a:solidFill>
-          <a:srgbClr val="141B45"/>
+          <a:srgbClr val="FFFFFF"/>
         </a:solidFill>
         <a:effectLst/>
       </p:bgPr>
@@ -9717,34 +9955,34 @@
         </p:nvSpPr>
         <p:spPr>
           <a:xfrm>
-            <a:off x="640080" y="457200"/>
-            <a:ext cx="7863840" cy="274320"/>
-          </a:xfrm>
-          <a:prstGeom prst="rect">
-            <a:avLst/>
-          </a:prstGeom>
-          <a:noFill/>
-          <a:ln/>
-        </p:spPr>
-        <p:txBody>
-          <a:bodyPr wrap="square" lIns="0" tIns="0" rIns="0" bIns="0" rtlCol="0" anchor="ctr"/>
-          <a:lstStyle/>
-          <a:p>
-            <a:pPr marL="0" indent="0">
-              <a:buNone/>
-            </a:pPr>
-            <a:r>
-              <a:rPr lang="en-US" sz="1200" b="1" kern="0" spc="400" dirty="0">
-                <a:solidFill>
-                  <a:srgbClr val="CADCFC"/>
-                </a:solidFill>
-                <a:latin typeface="Calibri" pitchFamily="34" charset="0"/>
-                <a:ea typeface="Calibri" pitchFamily="34" charset="-122"/>
-                <a:cs typeface="Calibri" pitchFamily="34" charset="-120"/>
-              </a:rPr>
-              <a:t>FIVE THINGS TO TAKE HOME</a:t>
-            </a:r>
-            <a:endParaRPr lang="en-US" sz="1200" dirty="0"/>
+            <a:off x="502920" y="274320"/>
+            <a:ext cx="8138160" cy="274320"/>
+          </a:xfrm>
+          <a:prstGeom prst="rect">
+            <a:avLst/>
+          </a:prstGeom>
+          <a:noFill/>
+          <a:ln/>
+        </p:spPr>
+        <p:txBody>
+          <a:bodyPr wrap="square" lIns="0" tIns="0" rIns="0" bIns="0" rtlCol="0" anchor="ctr"/>
+          <a:lstStyle/>
+          <a:p>
+            <a:pPr marL="0" indent="0">
+              <a:buNone/>
+            </a:pPr>
+            <a:r>
+              <a:rPr lang="en-US" sz="1100" b="1" kern="0" spc="300" dirty="0">
+                <a:solidFill>
+                  <a:srgbClr val="5A6378"/>
+                </a:solidFill>
+                <a:latin typeface="Calibri" pitchFamily="34" charset="0"/>
+                <a:ea typeface="Calibri" pitchFamily="34" charset="-122"/>
+                <a:cs typeface="Calibri" pitchFamily="34" charset="-120"/>
+              </a:rPr>
+              <a:t>GXP VARIANT · SCENARIO &amp; LIMITS</a:t>
+            </a:r>
+            <a:endParaRPr lang="en-US" sz="1100" dirty="0"/>
           </a:p>
         </p:txBody>
       </p:sp>
@@ -9756,8 +9994,8 @@
         </p:nvSpPr>
         <p:spPr>
           <a:xfrm>
-            <a:off x="640080" y="777240"/>
-            <a:ext cx="7863840" cy="548640"/>
+            <a:off x="502920" y="530352"/>
+            <a:ext cx="8138160" cy="685800"/>
           </a:xfrm>
           <a:prstGeom prst="rect">
             <a:avLst/>
@@ -9775,13 +10013,13 @@
             <a:r>
               <a:rPr lang="en-US" sz="3000" b="1" dirty="0">
                 <a:solidFill>
-                  <a:srgbClr val="FFFFFF"/>
+                  <a:srgbClr val="1E2761"/>
                 </a:solidFill>
                 <a:latin typeface="Cambria" pitchFamily="34" charset="0"/>
                 <a:ea typeface="Cambria" pitchFamily="34" charset="-122"/>
                 <a:cs typeface="Cambria" pitchFamily="34" charset="-120"/>
               </a:rPr>
-              <a:t>Evaluation is the production discipline</a:t>
+              <a:t>The GxP lab: refusals are the main event</a:t>
             </a:r>
             <a:endParaRPr lang="en-US" sz="3000" dirty="0"/>
           </a:p>
@@ -9789,151 +10027,53 @@
       </p:sp>
       <p:sp>
         <p:nvSpPr>
-          <p:cNvPr id="4" name="Text 2"/>
-          <p:cNvSpPr/>
-          <p:nvPr/>
-        </p:nvSpPr>
-        <p:spPr>
-          <a:xfrm>
-            <a:off x="685800" y="1600200"/>
-            <a:ext cx="7680960" cy="2286000"/>
-          </a:xfrm>
-          <a:prstGeom prst="rect">
-            <a:avLst/>
-          </a:prstGeom>
-          <a:noFill/>
-          <a:ln/>
-        </p:spPr>
-        <p:txBody>
-          <a:bodyPr wrap="square" rtlCol="0" anchor="ctr"/>
-          <a:lstStyle/>
-          <a:p>
-            <a:pPr marL="342900" indent="-342900">
-              <a:spcAft>
-                <a:spcPts val="1000"/>
-              </a:spcAft>
-              <a:buSzPct val="100000"/>
-              <a:buFont typeface="+mj-lt"/>
-              <a:buAutoNum type="arabicPeriod"/>
-            </a:pPr>
-            <a:r>
-              <a:rPr lang="en-US" sz="1400" dirty="0">
-                <a:solidFill>
-                  <a:srgbClr val="CADCFC"/>
-                </a:solidFill>
-                <a:latin typeface="Calibri" pitchFamily="34" charset="0"/>
-                <a:ea typeface="Calibri" pitchFamily="34" charset="-122"/>
-                <a:cs typeface="Calibri" pitchFamily="34" charset="-120"/>
-              </a:rPr>
-              <a:t>Lifecycle, not checkbox: local → CI/CD gate → continuous production monitoring → optimization loop.</a:t>
-            </a:r>
-            <a:endParaRPr lang="en-US" sz="1400" dirty="0"/>
-          </a:p>
-          <a:p>
-            <a:pPr marL="342900" indent="-342900">
-              <a:spcAft>
-                <a:spcPts val="1000"/>
-              </a:spcAft>
-              <a:buSzPct val="100000"/>
-              <a:buFont typeface="+mj-lt"/>
-              <a:buAutoNum type="arabicPeriod"/>
-            </a:pPr>
-            <a:r>
-              <a:rPr lang="en-US" sz="1400" dirty="0">
-                <a:solidFill>
-                  <a:srgbClr val="CADCFC"/>
-                </a:solidFill>
-                <a:latin typeface="Calibri" pitchFamily="34" charset="0"/>
-                <a:ea typeface="Calibri" pitchFamily="34" charset="-122"/>
-                <a:cs typeface="Calibri" pitchFamily="34" charset="-120"/>
-              </a:rPr>
-              <a:t>The taxonomy mirrors how agents fail: system evaluators for outcomes, process evaluators for tool-call execution.</a:t>
-            </a:r>
-            <a:endParaRPr lang="en-US" sz="1400" dirty="0"/>
-          </a:p>
-          <a:p>
-            <a:pPr marL="342900" indent="-342900">
-              <a:spcAft>
-                <a:spcPts val="1000"/>
-              </a:spcAft>
-              <a:buSzPct val="100000"/>
-              <a:buFont typeface="+mj-lt"/>
-              <a:buAutoNum type="arabicPeriod"/>
-            </a:pPr>
-            <a:r>
-              <a:rPr lang="en-US" sz="1400" dirty="0">
-                <a:solidFill>
-                  <a:srgbClr val="CADCFC"/>
-                </a:solidFill>
-                <a:latin typeface="Calibri" pitchFamily="34" charset="0"/>
-                <a:ea typeface="Calibri" pitchFamily="34" charset="-122"/>
-                <a:cs typeface="Calibri" pitchFamily="34" charset="-120"/>
-              </a:rPr>
-              <a:t>Trace-based evaluation removes the dataset bottleneck — any framework, any cloud, via OpenTelemetry.</a:t>
-            </a:r>
-            <a:endParaRPr lang="en-US" sz="1400" dirty="0"/>
-          </a:p>
-          <a:p>
-            <a:pPr marL="342900" indent="-342900">
-              <a:spcAft>
-                <a:spcPts val="1000"/>
-              </a:spcAft>
-              <a:buSzPct val="100000"/>
-              <a:buFont typeface="+mj-lt"/>
-              <a:buAutoNum type="arabicPeriod"/>
-            </a:pPr>
-            <a:r>
-              <a:rPr lang="en-US" sz="1400" dirty="0">
-                <a:solidFill>
-                  <a:srgbClr val="CADCFC"/>
-                </a:solidFill>
-                <a:latin typeface="Calibri" pitchFamily="34" charset="0"/>
-                <a:ea typeface="Calibri" pitchFamily="34" charset="-122"/>
-                <a:cs typeface="Calibri" pitchFamily="34" charset="-120"/>
-              </a:rPr>
-              <a:t>Rubric evaluator + Agent Optimizer attack the two hardest problems: writing criteria and acting on results.</a:t>
-            </a:r>
-            <a:endParaRPr lang="en-US" sz="1400" dirty="0"/>
-          </a:p>
-          <a:p>
-            <a:pPr marL="342900" indent="-342900">
-              <a:spcAft>
-                <a:spcPts val="1000"/>
-              </a:spcAft>
-              <a:buSzPct val="100000"/>
-              <a:buFont typeface="+mj-lt"/>
-              <a:buAutoNum type="arabicPeriod"/>
-            </a:pPr>
-            <a:r>
-              <a:rPr lang="en-US" sz="1400" dirty="0">
-                <a:solidFill>
-                  <a:srgbClr val="CADCFC"/>
-                </a:solidFill>
-                <a:latin typeface="Calibri" pitchFamily="34" charset="0"/>
-                <a:ea typeface="Calibri" pitchFamily="34" charset="-122"/>
-                <a:cs typeface="Calibri" pitchFamily="34" charset="-120"/>
-              </a:rPr>
-              <a:t>Results are only as trustworthy as your judge model, rubric, and data mappings — invest there first.</a:t>
-            </a:r>
-            <a:endParaRPr lang="en-US" sz="1400" dirty="0"/>
-          </a:p>
-        </p:txBody>
-      </p:sp>
-      <p:sp>
-        <p:nvSpPr>
-          <p:cNvPr id="5" name="Shape 3"/>
-          <p:cNvSpPr/>
-          <p:nvPr/>
-        </p:nvSpPr>
-        <p:spPr>
-          <a:xfrm>
-            <a:off x="640080" y="4069080"/>
-            <a:ext cx="7863840" cy="685800"/>
+          <p:cNvPr id="4" name="Shape 2"/>
+          <p:cNvSpPr/>
+          <p:nvPr/>
+        </p:nvSpPr>
+        <p:spPr>
+          <a:xfrm>
+            <a:off x="502920" y="1417320"/>
+            <a:ext cx="3950208" cy="3246120"/>
           </a:xfrm>
           <a:prstGeom prst="roundRect">
             <a:avLst>
-              <a:gd name="adj" fmla="val 8000"/>
+              <a:gd name="adj" fmla="val 1690"/>
             </a:avLst>
+          </a:prstGeom>
+          <a:solidFill>
+            <a:srgbClr val="EEF4FE"/>
+          </a:solidFill>
+          <a:ln/>
+          <a:effectLst>
+            <a:outerShdw blurRad="88900" dist="25400" dir="2700000" algn="bl" rotWithShape="0">
+              <a:srgbClr val="000000">
+                <a:alpha val="14000"/>
+              </a:srgbClr>
+            </a:outerShdw>
+          </a:effectLst>
+        </p:spPr>
+        <p:txBody>
+          <a:bodyPr/>
+          <a:lstStyle/>
+          <a:p>
+            <a:endParaRPr lang="en-GB"/>
+          </a:p>
+        </p:txBody>
+      </p:sp>
+      <p:sp>
+        <p:nvSpPr>
+          <p:cNvPr id="5" name="Shape 3"/>
+          <p:cNvSpPr/>
+          <p:nvPr/>
+        </p:nvSpPr>
+        <p:spPr>
+          <a:xfrm>
+            <a:off x="685800" y="1600200"/>
+            <a:ext cx="457200" cy="457200"/>
+          </a:xfrm>
+          <a:prstGeom prst="ellipse">
+            <a:avLst/>
           </a:prstGeom>
           <a:solidFill>
             <a:srgbClr val="1E2761"/>
@@ -9948,32 +10088,264 @@
           </a:p>
         </p:txBody>
       </p:sp>
-      <p:sp>
-        <p:nvSpPr>
-          <p:cNvPr id="6" name="Text 4"/>
-          <p:cNvSpPr/>
-          <p:nvPr/>
-        </p:nvSpPr>
-        <p:spPr>
-          <a:xfrm>
-            <a:off x="868680" y="4160520"/>
-            <a:ext cx="7406640" cy="502920"/>
-          </a:xfrm>
-          <a:prstGeom prst="rect">
-            <a:avLst/>
-          </a:prstGeom>
-          <a:noFill/>
-          <a:ln/>
-        </p:spPr>
-        <p:txBody>
-          <a:bodyPr wrap="square" lIns="0" tIns="0" rIns="0" bIns="0" rtlCol="0" anchor="ctr"/>
-          <a:lstStyle/>
-          <a:p>
-            <a:pPr marL="0" indent="0">
-              <a:buNone/>
-            </a:pPr>
-            <a:r>
-              <a:rPr lang="en-US" sz="1100" b="1" dirty="0">
+      <p:pic>
+        <p:nvPicPr>
+          <p:cNvPr id="6" name="Image 0" descr="preencoded.png"/>
+          <p:cNvPicPr>
+            <a:picLocks noChangeAspect="1"/>
+          </p:cNvPicPr>
+          <p:nvPr/>
+        </p:nvPicPr>
+        <p:blipFill>
+          <a:blip r:embed="rId3"/>
+          <a:stretch>
+            <a:fillRect/>
+          </a:stretch>
+        </p:blipFill>
+        <p:spPr>
+          <a:xfrm>
+            <a:off x="804672" y="1719072"/>
+            <a:ext cx="219456" cy="219456"/>
+          </a:xfrm>
+          <a:prstGeom prst="rect">
+            <a:avLst/>
+          </a:prstGeom>
+        </p:spPr>
+      </p:pic>
+      <p:sp>
+        <p:nvSpPr>
+          <p:cNvPr id="7" name="Text 4"/>
+          <p:cNvSpPr/>
+          <p:nvPr/>
+        </p:nvSpPr>
+        <p:spPr>
+          <a:xfrm>
+            <a:off x="1280160" y="1664208"/>
+            <a:ext cx="3063240" cy="365760"/>
+          </a:xfrm>
+          <a:prstGeom prst="rect">
+            <a:avLst/>
+          </a:prstGeom>
+          <a:noFill/>
+          <a:ln/>
+        </p:spPr>
+        <p:txBody>
+          <a:bodyPr wrap="square" lIns="0" tIns="0" rIns="0" bIns="0" rtlCol="0" anchor="ctr"/>
+          <a:lstStyle/>
+          <a:p>
+            <a:pPr marL="0" indent="0">
+              <a:buNone/>
+            </a:pPr>
+            <a:r>
+              <a:rPr lang="en-US" sz="1350" b="1" dirty="0">
+                <a:solidFill>
+                  <a:srgbClr val="1E2761"/>
+                </a:solidFill>
+                <a:latin typeface="Calibri" pitchFamily="34" charset="0"/>
+                <a:ea typeface="Calibri" pitchFamily="34" charset="-122"/>
+                <a:cs typeface="Calibri" pitchFamily="34" charset="-120"/>
+              </a:rPr>
+              <a:t>SOP &amp; deviation-triage assistant</a:t>
+            </a:r>
+            <a:endParaRPr lang="en-US" sz="1350" dirty="0"/>
+          </a:p>
+        </p:txBody>
+      </p:sp>
+      <p:sp>
+        <p:nvSpPr>
+          <p:cNvPr id="8" name="Text 5"/>
+          <p:cNvSpPr/>
+          <p:nvPr/>
+        </p:nvSpPr>
+        <p:spPr>
+          <a:xfrm>
+            <a:off x="731520" y="2194560"/>
+            <a:ext cx="3520440" cy="2377440"/>
+          </a:xfrm>
+          <a:prstGeom prst="rect">
+            <a:avLst/>
+          </a:prstGeom>
+          <a:noFill/>
+          <a:ln/>
+        </p:spPr>
+        <p:txBody>
+          <a:bodyPr wrap="square" rtlCol="0" anchor="ctr"/>
+          <a:lstStyle/>
+          <a:p>
+            <a:pPr marL="342900" indent="-342900">
+              <a:spcAft>
+                <a:spcPts val="600"/>
+              </a:spcAft>
+              <a:buSzPct val="100000"/>
+              <a:buChar char="•"/>
+            </a:pPr>
+            <a:r>
+              <a:rPr lang="en-US" sz="1100" dirty="0">
+                <a:solidFill>
+                  <a:srgbClr val="20263F"/>
+                </a:solidFill>
+                <a:latin typeface="Calibri" pitchFamily="34" charset="0"/>
+                <a:ea typeface="Calibri" pitchFamily="34" charset="-122"/>
+                <a:cs typeface="Calibri" pitchFamily="34" charset="-120"/>
+              </a:rPr>
+              <a:t>Answers SOP questions; helps classify deviations — must refuse release decisions, change approvals, and ALCOA+ violations · one of four discipline tracks (next slide)</a:t>
+            </a:r>
+            <a:endParaRPr lang="en-US" sz="1100" dirty="0"/>
+          </a:p>
+          <a:p>
+            <a:pPr marL="342900" indent="-342900">
+              <a:spcAft>
+                <a:spcPts val="600"/>
+              </a:spcAft>
+              <a:buSzPct val="100000"/>
+              <a:buChar char="•"/>
+            </a:pPr>
+            <a:r>
+              <a:rPr lang="en-US" sz="1100" dirty="0">
+                <a:solidFill>
+                  <a:srgbClr val="20263F"/>
+                </a:solidFill>
+                <a:latin typeface="Calibri" pitchFamily="34" charset="0"/>
+                <a:ea typeface="Calibri" pitchFamily="34" charset="-122"/>
+                <a:cs typeface="Calibri" pitchFamily="34" charset="-120"/>
+              </a:rPr>
+              <a:t>Data-integrity traps (“just backdate it”) are the core test — a failure here is a validation failure regardless of answer quality</a:t>
+            </a:r>
+            <a:endParaRPr lang="en-US" sz="1100" dirty="0"/>
+          </a:p>
+          <a:p>
+            <a:pPr marL="342900" indent="-342900">
+              <a:buSzPct val="100000"/>
+              <a:buChar char="•"/>
+            </a:pPr>
+            <a:r>
+              <a:rPr lang="en-US" sz="1100" dirty="0">
+                <a:solidFill>
+                  <a:srgbClr val="20263F"/>
+                </a:solidFill>
+                <a:latin typeface="Calibri" pitchFamily="34" charset="0"/>
+                <a:ea typeface="Calibri" pitchFamily="34" charset="-122"/>
+                <a:cs typeface="Calibri" pitchFamily="34" charset="-120"/>
+              </a:rPr>
+              <a:t>Evaluators: Task Adherence + Intent Resolution + Groundedness + a custom ALCOA+ adherence rubric (Module 3B exercise)</a:t>
+            </a:r>
+            <a:endParaRPr lang="en-US" sz="1100" dirty="0"/>
+          </a:p>
+        </p:txBody>
+      </p:sp>
+      <p:sp>
+        <p:nvSpPr>
+          <p:cNvPr id="9" name="Shape 6"/>
+          <p:cNvSpPr/>
+          <p:nvPr/>
+        </p:nvSpPr>
+        <p:spPr>
+          <a:xfrm>
+            <a:off x="4690872" y="1417320"/>
+            <a:ext cx="3950208" cy="3246120"/>
+          </a:xfrm>
+          <a:prstGeom prst="roundRect">
+            <a:avLst>
+              <a:gd name="adj" fmla="val 1690"/>
+            </a:avLst>
+          </a:prstGeom>
+          <a:solidFill>
+            <a:srgbClr val="1E2761"/>
+          </a:solidFill>
+          <a:ln/>
+          <a:effectLst>
+            <a:outerShdw blurRad="88900" dist="25400" dir="2700000" algn="bl" rotWithShape="0">
+              <a:srgbClr val="000000">
+                <a:alpha val="14000"/>
+              </a:srgbClr>
+            </a:outerShdw>
+          </a:effectLst>
+        </p:spPr>
+        <p:txBody>
+          <a:bodyPr/>
+          <a:lstStyle/>
+          <a:p>
+            <a:endParaRPr lang="en-GB"/>
+          </a:p>
+        </p:txBody>
+      </p:sp>
+      <p:sp>
+        <p:nvSpPr>
+          <p:cNvPr id="10" name="Shape 7"/>
+          <p:cNvSpPr/>
+          <p:nvPr/>
+        </p:nvSpPr>
+        <p:spPr>
+          <a:xfrm>
+            <a:off x="4873752" y="1600200"/>
+            <a:ext cx="457200" cy="457200"/>
+          </a:xfrm>
+          <a:prstGeom prst="ellipse">
+            <a:avLst/>
+          </a:prstGeom>
+          <a:solidFill>
+            <a:srgbClr val="D4544F"/>
+          </a:solidFill>
+          <a:ln/>
+        </p:spPr>
+        <p:txBody>
+          <a:bodyPr/>
+          <a:lstStyle/>
+          <a:p>
+            <a:endParaRPr lang="en-GB"/>
+          </a:p>
+        </p:txBody>
+      </p:sp>
+      <p:pic>
+        <p:nvPicPr>
+          <p:cNvPr id="11" name="Image 1" descr="preencoded.png"/>
+          <p:cNvPicPr>
+            <a:picLocks noChangeAspect="1"/>
+          </p:cNvPicPr>
+          <p:nvPr/>
+        </p:nvPicPr>
+        <p:blipFill>
+          <a:blip r:embed="rId4"/>
+          <a:stretch>
+            <a:fillRect/>
+          </a:stretch>
+        </p:blipFill>
+        <p:spPr>
+          <a:xfrm>
+            <a:off x="4992624" y="1719072"/>
+            <a:ext cx="219456" cy="219456"/>
+          </a:xfrm>
+          <a:prstGeom prst="rect">
+            <a:avLst/>
+          </a:prstGeom>
+        </p:spPr>
+      </p:pic>
+      <p:sp>
+        <p:nvSpPr>
+          <p:cNvPr id="12" name="Text 8"/>
+          <p:cNvSpPr/>
+          <p:nvPr/>
+        </p:nvSpPr>
+        <p:spPr>
+          <a:xfrm>
+            <a:off x="5468112" y="1664208"/>
+            <a:ext cx="3108960" cy="365760"/>
+          </a:xfrm>
+          <a:prstGeom prst="rect">
+            <a:avLst/>
+          </a:prstGeom>
+          <a:noFill/>
+          <a:ln/>
+        </p:spPr>
+        <p:txBody>
+          <a:bodyPr wrap="square" lIns="0" tIns="0" rIns="0" bIns="0" rtlCol="0" anchor="ctr"/>
+          <a:lstStyle/>
+          <a:p>
+            <a:pPr marL="0" indent="0">
+              <a:buNone/>
+            </a:pPr>
+            <a:r>
+              <a:rPr lang="en-US" sz="1350" b="1" dirty="0">
                 <a:solidFill>
                   <a:srgbClr val="FFFFFF"/>
                 </a:solidFill>
@@ -9981,8 +10353,40 @@
                 <a:ea typeface="Calibri" pitchFamily="34" charset="-122"/>
                 <a:cs typeface="Calibri" pitchFamily="34" charset="-120"/>
               </a:rPr>
-              <a:t>Resources:  </a:t>
-            </a:r>
+              <a:t>What Foundry does NOT close</a:t>
+            </a:r>
+            <a:endParaRPr lang="en-US" sz="1350" dirty="0"/>
+          </a:p>
+        </p:txBody>
+      </p:sp>
+      <p:sp>
+        <p:nvSpPr>
+          <p:cNvPr id="13" name="Text 9"/>
+          <p:cNvSpPr/>
+          <p:nvPr/>
+        </p:nvSpPr>
+        <p:spPr>
+          <a:xfrm>
+            <a:off x="4919472" y="2194560"/>
+            <a:ext cx="3520440" cy="2377440"/>
+          </a:xfrm>
+          <a:prstGeom prst="rect">
+            <a:avLst/>
+          </a:prstGeom>
+          <a:noFill/>
+          <a:ln/>
+        </p:spPr>
+        <p:txBody>
+          <a:bodyPr wrap="square" rtlCol="0" anchor="ctr"/>
+          <a:lstStyle/>
+          <a:p>
+            <a:pPr marL="342900" indent="-342900">
+              <a:spcAft>
+                <a:spcPts val="600"/>
+              </a:spcAft>
+              <a:buSzPct val="100000"/>
+              <a:buChar char="•"/>
+            </a:pPr>
             <a:r>
               <a:rPr lang="en-US" sz="1100" dirty="0">
                 <a:solidFill>
@@ -9992,7 +10396,67 @@
                 <a:ea typeface="Calibri" pitchFamily="34" charset="-122"/>
                 <a:cs typeface="Calibri" pitchFamily="34" charset="-120"/>
               </a:rPr>
-              <a:t>learn.microsoft.com → Foundry → Observability → Evaluations   ·   open-sourced quality rubrics: Azure AI Evaluation SDK repo   ·   Build 2026 on-demand: BRK250, BRK252, LAB540</a:t>
+              <a:t>No such thing as “GxP-certified” tooling — validation responsibility stays yours under GAMP 5</a:t>
+            </a:r>
+            <a:endParaRPr lang="en-US" sz="1100" dirty="0"/>
+          </a:p>
+          <a:p>
+            <a:pPr marL="342900" indent="-342900">
+              <a:spcAft>
+                <a:spcPts val="600"/>
+              </a:spcAft>
+              <a:buSzPct val="100000"/>
+              <a:buChar char="•"/>
+            </a:pPr>
+            <a:r>
+              <a:rPr lang="en-US" sz="1100" dirty="0">
+                <a:solidFill>
+                  <a:srgbClr val="CADCFC"/>
+                </a:solidFill>
+                <a:latin typeface="Calibri" pitchFamily="34" charset="0"/>
+                <a:ea typeface="Calibri" pitchFamily="34" charset="-122"/>
+                <a:cs typeface="Calibri" pitchFamily="34" charset="-120"/>
+              </a:rPr>
+              <a:t>The judge model is validated software too: pin it, document it, re-baseline on change</a:t>
+            </a:r>
+            <a:endParaRPr lang="en-US" sz="1100" dirty="0"/>
+          </a:p>
+          <a:p>
+            <a:pPr marL="342900" indent="-342900">
+              <a:spcAft>
+                <a:spcPts val="600"/>
+              </a:spcAft>
+              <a:buSzPct val="100000"/>
+              <a:buChar char="•"/>
+            </a:pPr>
+            <a:r>
+              <a:rPr lang="en-US" sz="1100" dirty="0">
+                <a:solidFill>
+                  <a:srgbClr val="CADCFC"/>
+                </a:solidFill>
+                <a:latin typeface="Calibri" pitchFamily="34" charset="0"/>
+                <a:ea typeface="Calibri" pitchFamily="34" charset="-122"/>
+                <a:cs typeface="Calibri" pitchFamily="34" charset="-120"/>
+              </a:rPr>
+              <a:t>Retention &amp; tamper-evidence need explicit design against your Part 11 interpretation</a:t>
+            </a:r>
+            <a:endParaRPr lang="en-US" sz="1100" dirty="0"/>
+          </a:p>
+          <a:p>
+            <a:pPr marL="342900" indent="-342900">
+              <a:buSzPct val="100000"/>
+              <a:buChar char="•"/>
+            </a:pPr>
+            <a:r>
+              <a:rPr lang="en-US" sz="1100" dirty="0">
+                <a:solidFill>
+                  <a:srgbClr val="CADCFC"/>
+                </a:solidFill>
+                <a:latin typeface="Calibri" pitchFamily="34" charset="0"/>
+                <a:ea typeface="Calibri" pitchFamily="34" charset="-122"/>
+                <a:cs typeface="Calibri" pitchFamily="34" charset="-120"/>
+              </a:rPr>
+              <a:t>Human oversight is a process control (SOPs), not a product feature</a:t>
             </a:r>
             <a:endParaRPr lang="en-US" sz="1100" dirty="0"/>
           </a:p>
@@ -10765,6 +11229,324 @@
 </p:sld>
 </file>
 
+<file path=ppt/slides/slide22.xml><?xml version="1.0" encoding="utf-8"?>
+<p:sld xmlns:a="http://schemas.openxmlformats.org/drawingml/2006/main" xmlns:r="http://schemas.openxmlformats.org/officeDocument/2006/relationships" xmlns:p="http://schemas.openxmlformats.org/presentationml/2006/main">
+  <p:cSld name="Slide 20">
+    <p:bg>
+      <p:bgPr>
+        <a:solidFill>
+          <a:srgbClr val="141B45"/>
+        </a:solidFill>
+        <a:effectLst/>
+      </p:bgPr>
+    </p:bg>
+    <p:spTree>
+      <p:nvGrpSpPr>
+        <p:cNvPr id="1" name=""/>
+        <p:cNvGrpSpPr/>
+        <p:nvPr/>
+      </p:nvGrpSpPr>
+      <p:grpSpPr>
+        <a:xfrm>
+          <a:off x="0" y="0"/>
+          <a:ext cx="0" cy="0"/>
+          <a:chOff x="0" y="0"/>
+          <a:chExt cx="0" cy="0"/>
+        </a:xfrm>
+      </p:grpSpPr>
+      <p:sp>
+        <p:nvSpPr>
+          <p:cNvPr id="2" name="Text 0"/>
+          <p:cNvSpPr/>
+          <p:nvPr/>
+        </p:nvSpPr>
+        <p:spPr>
+          <a:xfrm>
+            <a:off x="640080" y="457200"/>
+            <a:ext cx="7863840" cy="274320"/>
+          </a:xfrm>
+          <a:prstGeom prst="rect">
+            <a:avLst/>
+          </a:prstGeom>
+          <a:noFill/>
+          <a:ln/>
+        </p:spPr>
+        <p:txBody>
+          <a:bodyPr wrap="square" lIns="0" tIns="0" rIns="0" bIns="0" rtlCol="0" anchor="ctr"/>
+          <a:lstStyle/>
+          <a:p>
+            <a:pPr marL="0" indent="0">
+              <a:buNone/>
+            </a:pPr>
+            <a:r>
+              <a:rPr lang="en-US" sz="1200" b="1" kern="0" spc="400" dirty="0">
+                <a:solidFill>
+                  <a:srgbClr val="CADCFC"/>
+                </a:solidFill>
+                <a:latin typeface="Calibri" pitchFamily="34" charset="0"/>
+                <a:ea typeface="Calibri" pitchFamily="34" charset="-122"/>
+                <a:cs typeface="Calibri" pitchFamily="34" charset="-120"/>
+              </a:rPr>
+              <a:t>FIVE THINGS TO TAKE HOME</a:t>
+            </a:r>
+            <a:endParaRPr lang="en-US" sz="1200" dirty="0"/>
+          </a:p>
+        </p:txBody>
+      </p:sp>
+      <p:sp>
+        <p:nvSpPr>
+          <p:cNvPr id="3" name="Text 1"/>
+          <p:cNvSpPr/>
+          <p:nvPr/>
+        </p:nvSpPr>
+        <p:spPr>
+          <a:xfrm>
+            <a:off x="640080" y="777240"/>
+            <a:ext cx="7863840" cy="548640"/>
+          </a:xfrm>
+          <a:prstGeom prst="rect">
+            <a:avLst/>
+          </a:prstGeom>
+          <a:noFill/>
+          <a:ln/>
+        </p:spPr>
+        <p:txBody>
+          <a:bodyPr wrap="square" lIns="0" tIns="0" rIns="0" bIns="0" rtlCol="0" anchor="ctr"/>
+          <a:lstStyle/>
+          <a:p>
+            <a:pPr marL="0" indent="0">
+              <a:buNone/>
+            </a:pPr>
+            <a:r>
+              <a:rPr lang="en-US" sz="3000" b="1" dirty="0">
+                <a:solidFill>
+                  <a:srgbClr val="FFFFFF"/>
+                </a:solidFill>
+                <a:latin typeface="Cambria" pitchFamily="34" charset="0"/>
+                <a:ea typeface="Cambria" pitchFamily="34" charset="-122"/>
+                <a:cs typeface="Cambria" pitchFamily="34" charset="-120"/>
+              </a:rPr>
+              <a:t>Evaluation is the production discipline</a:t>
+            </a:r>
+            <a:endParaRPr lang="en-US" sz="3000" dirty="0"/>
+          </a:p>
+        </p:txBody>
+      </p:sp>
+      <p:sp>
+        <p:nvSpPr>
+          <p:cNvPr id="4" name="Text 2"/>
+          <p:cNvSpPr/>
+          <p:nvPr/>
+        </p:nvSpPr>
+        <p:spPr>
+          <a:xfrm>
+            <a:off x="685800" y="1600200"/>
+            <a:ext cx="7680960" cy="2286000"/>
+          </a:xfrm>
+          <a:prstGeom prst="rect">
+            <a:avLst/>
+          </a:prstGeom>
+          <a:noFill/>
+          <a:ln/>
+        </p:spPr>
+        <p:txBody>
+          <a:bodyPr wrap="square" rtlCol="0" anchor="ctr"/>
+          <a:lstStyle/>
+          <a:p>
+            <a:pPr marL="342900" indent="-342900">
+              <a:spcAft>
+                <a:spcPts val="1000"/>
+              </a:spcAft>
+              <a:buSzPct val="100000"/>
+              <a:buFont typeface="+mj-lt"/>
+              <a:buAutoNum type="arabicPeriod"/>
+            </a:pPr>
+            <a:r>
+              <a:rPr lang="en-US" sz="1400" dirty="0">
+                <a:solidFill>
+                  <a:srgbClr val="CADCFC"/>
+                </a:solidFill>
+                <a:latin typeface="Calibri" pitchFamily="34" charset="0"/>
+                <a:ea typeface="Calibri" pitchFamily="34" charset="-122"/>
+                <a:cs typeface="Calibri" pitchFamily="34" charset="-120"/>
+              </a:rPr>
+              <a:t>Lifecycle, not checkbox: live smoke test → CI/CD gate → continuous monitoring → optimization.</a:t>
+            </a:r>
+            <a:endParaRPr lang="en-US" sz="1400" dirty="0"/>
+          </a:p>
+          <a:p>
+            <a:pPr marL="342900" indent="-342900">
+              <a:spcAft>
+                <a:spcPts val="1000"/>
+              </a:spcAft>
+              <a:buSzPct val="100000"/>
+              <a:buFont typeface="+mj-lt"/>
+              <a:buAutoNum type="arabicPeriod"/>
+            </a:pPr>
+            <a:r>
+              <a:rPr lang="en-US" sz="1400" dirty="0">
+                <a:solidFill>
+                  <a:srgbClr val="CADCFC"/>
+                </a:solidFill>
+                <a:latin typeface="Calibri" pitchFamily="34" charset="0"/>
+                <a:ea typeface="Calibri" pitchFamily="34" charset="-122"/>
+                <a:cs typeface="Calibri" pitchFamily="34" charset="-120"/>
+              </a:rPr>
+              <a:t>System evaluators judge outcomes; process evaluators judge tool-call execution.</a:t>
+            </a:r>
+          </a:p>
+          <a:p>
+            <a:pPr marL="342900" indent="-342900">
+              <a:spcAft>
+                <a:spcPts val="1000"/>
+              </a:spcAft>
+              <a:buSzPct val="100000"/>
+              <a:buFont typeface="+mj-lt"/>
+              <a:buAutoNum type="arabicPeriod"/>
+            </a:pPr>
+            <a:r>
+              <a:rPr lang="en-US" sz="1400" dirty="0">
+                <a:solidFill>
+                  <a:srgbClr val="CADCFC"/>
+                </a:solidFill>
+                <a:latin typeface="Calibri" pitchFamily="34" charset="0"/>
+                <a:ea typeface="Calibri" pitchFamily="34" charset="-122"/>
+                <a:cs typeface="Calibri" pitchFamily="34" charset="-120"/>
+              </a:rPr>
+              <a:t>Deterministic contracts + explicit policy complement LLM judges — they do different jobs.</a:t>
+            </a:r>
+          </a:p>
+          <a:p>
+            <a:pPr marL="342900" indent="-342900">
+              <a:spcAft>
+                <a:spcPts val="1000"/>
+              </a:spcAft>
+              <a:buSzPct val="100000"/>
+              <a:buFont typeface="+mj-lt"/>
+              <a:buAutoNum type="arabicPeriod"/>
+            </a:pPr>
+            <a:r>
+              <a:rPr lang="en-US" sz="1400" dirty="0">
+                <a:solidFill>
+                  <a:srgbClr val="CADCFC"/>
+                </a:solidFill>
+                <a:latin typeface="Calibri" pitchFamily="34" charset="0"/>
+                <a:ea typeface="Calibri" pitchFamily="34" charset="-122"/>
+                <a:cs typeface="Calibri" pitchFamily="34" charset="-120"/>
+              </a:rPr>
+              <a:t>Trace-based evaluation measures production behavior across frameworks via OpenTelemetry.</a:t>
+            </a:r>
+          </a:p>
+          <a:p>
+            <a:pPr marL="342900" indent="-342900">
+              <a:spcAft>
+                <a:spcPts val="1000"/>
+              </a:spcAft>
+              <a:buSzPct val="100000"/>
+              <a:buFont typeface="+mj-lt"/>
+              <a:buAutoNum type="arabicPeriod"/>
+            </a:pPr>
+            <a:r>
+              <a:rPr lang="en-US" sz="1400" dirty="0">
+                <a:solidFill>
+                  <a:srgbClr val="CADCFC"/>
+                </a:solidFill>
+                <a:latin typeface="Calibri" pitchFamily="34" charset="0"/>
+                <a:ea typeface="Calibri" pitchFamily="34" charset="-122"/>
+                <a:cs typeface="Calibri" pitchFamily="34" charset="-120"/>
+              </a:rPr>
+              <a:t>Trust requires controlled data, mappings, judge, criteria, artifacts, and provenance.</a:t>
+            </a:r>
+          </a:p>
+        </p:txBody>
+      </p:sp>
+      <p:sp>
+        <p:nvSpPr>
+          <p:cNvPr id="5" name="Shape 3"/>
+          <p:cNvSpPr/>
+          <p:nvPr/>
+        </p:nvSpPr>
+        <p:spPr>
+          <a:xfrm>
+            <a:off x="640080" y="4069080"/>
+            <a:ext cx="7863840" cy="685800"/>
+          </a:xfrm>
+          <a:prstGeom prst="roundRect">
+            <a:avLst>
+              <a:gd name="adj" fmla="val 8000"/>
+            </a:avLst>
+          </a:prstGeom>
+          <a:solidFill>
+            <a:srgbClr val="1E2761"/>
+          </a:solidFill>
+          <a:ln/>
+        </p:spPr>
+        <p:txBody>
+          <a:bodyPr/>
+          <a:lstStyle/>
+          <a:p>
+            <a:endParaRPr lang="en-GB"/>
+          </a:p>
+        </p:txBody>
+      </p:sp>
+      <p:sp>
+        <p:nvSpPr>
+          <p:cNvPr id="6" name="Text 4"/>
+          <p:cNvSpPr/>
+          <p:nvPr/>
+        </p:nvSpPr>
+        <p:spPr>
+          <a:xfrm>
+            <a:off x="868680" y="4160520"/>
+            <a:ext cx="7406640" cy="502920"/>
+          </a:xfrm>
+          <a:prstGeom prst="rect">
+            <a:avLst/>
+          </a:prstGeom>
+          <a:noFill/>
+          <a:ln/>
+        </p:spPr>
+        <p:txBody>
+          <a:bodyPr wrap="square" lIns="0" tIns="0" rIns="0" bIns="0" rtlCol="0" anchor="ctr"/>
+          <a:lstStyle/>
+          <a:p>
+            <a:pPr marL="0" indent="0">
+              <a:buNone/>
+            </a:pPr>
+            <a:r>
+              <a:rPr lang="en-US" sz="1100" b="1" dirty="0">
+                <a:solidFill>
+                  <a:srgbClr val="FFFFFF"/>
+                </a:solidFill>
+                <a:latin typeface="Calibri" pitchFamily="34" charset="0"/>
+                <a:ea typeface="Calibri" pitchFamily="34" charset="-122"/>
+                <a:cs typeface="Calibri" pitchFamily="34" charset="-120"/>
+              </a:rPr>
+              <a:t>Resources:  </a:t>
+            </a:r>
+            <a:r>
+              <a:rPr lang="en-US" sz="1100" dirty="0">
+                <a:solidFill>
+                  <a:srgbClr val="CADCFC"/>
+                </a:solidFill>
+                <a:latin typeface="Calibri" pitchFamily="34" charset="0"/>
+                <a:ea typeface="Calibri" pitchFamily="34" charset="-122"/>
+                <a:cs typeface="Calibri" pitchFamily="34" charset="-120"/>
+              </a:rPr>
+              <a:t>learn.microsoft.com → Foundry → Observability → Evaluations   ·   open-sourced quality rubrics: Azure AI Evaluation SDK repo   ·   Build 2026 on-demand: BRK250, BRK252, LAB540</a:t>
+            </a:r>
+            <a:endParaRPr lang="en-US" sz="1100" dirty="0"/>
+          </a:p>
+        </p:txBody>
+      </p:sp>
+    </p:spTree>
+  </p:cSld>
+  <p:clrMapOvr>
+    <a:masterClrMapping/>
+  </p:clrMapOvr>
+</p:sld>
+</file>
+
 <file path=ppt/slides/slide3.xml><?xml version="1.0" encoding="utf-8"?>
 <p:sld xmlns:a="http://schemas.openxmlformats.org/drawingml/2006/main" xmlns:r="http://schemas.openxmlformats.org/officeDocument/2006/relationships" xmlns:p="http://schemas.openxmlformats.org/presentationml/2006/main">
   <p:cSld name="Slide 3">
@@ -15610,7 +16392,7 @@
                 <a:ea typeface="Cambria" pitchFamily="34" charset="-122"/>
                 <a:cs typeface="Cambria" pitchFamily="34" charset="-120"/>
               </a:rPr>
-              <a:t>Lab 1 — Run the same evaluation twice: portal, then SDK</a:t>
+              <a:t>Lab 1 — Verify live Foundry, then evaluate: portal + SDK</a:t>
             </a:r>
             <a:endParaRPr lang="en-US" sz="3000" dirty="0"/>
           </a:p>
@@ -15700,7 +16482,7 @@
                 <a:ea typeface="Calibri" pitchFamily="34" charset="-122"/>
                 <a:cs typeface="Calibri" pitchFamily="34" charset="-120"/>
               </a:rPr>
-              <a:t>PART A — PORTAL (20 MIN)</a:t>
+              <a:t>PART A — LIVE SMOKE + PORTAL (25 MIN)</a:t>
             </a:r>
             <a:endParaRPr lang="en-US" sz="1100" dirty="0"/>
           </a:p>
@@ -15744,7 +16526,7 @@
                 <a:ea typeface="Calibri" pitchFamily="34" charset="-122"/>
                 <a:cs typeface="Calibri" pitchFamily="34" charset="-120"/>
               </a:rPr>
-              <a:t>Evaluation → Create → Agent → Full conversations → Simulated data</a:t>
+              <a:t>check_setup.py → every line [OK]</a:t>
             </a:r>
             <a:endParaRPr lang="en-US" sz="1200" dirty="0"/>
           </a:p>
@@ -15766,9 +16548,8 @@
                 <a:ea typeface="Calibri" pitchFamily="34" charset="-122"/>
                 <a:cs typeface="Calibri" pitchFamily="34" charset="-120"/>
               </a:rPr>
-              <a:t>Use the pre-uploaded dataset (synthetic generation exists — later)</a:t>
-            </a:r>
-            <a:endParaRPr lang="en-US" sz="1200" dirty="0"/>
+              <a:t>create_agent.py → real Foundry agent version</a:t>
+            </a:r>
           </a:p>
           <a:p>
             <a:pPr marL="342900" indent="-342900">
@@ -15788,12 +16569,14 @@
                 <a:ea typeface="Calibri" pitchFamily="34" charset="-122"/>
                 <a:cs typeface="Calibri" pitchFamily="34" charset="-120"/>
               </a:rPr>
-              <a:t>Pick evaluators: Task Adherence, Relevance, Violence (+ Rubric if available)</a:t>
-            </a:r>
-            <a:endParaRPr lang="en-US" sz="1200" dirty="0"/>
+              <a:t>run_agent.py --query ‘Weather in Truro?’ → tool call + result + grounded answer</a:t>
+            </a:r>
           </a:p>
           <a:p>
             <a:pPr marL="342900" indent="-342900">
+              <a:spcAft>
+                <a:spcPts val="500"/>
+              </a:spcAft>
               <a:buSzPct val="100000"/>
               <a:buFont typeface="+mj-lt"/>
               <a:buAutoNum type="arabicPeriod"/>
@@ -15807,9 +16590,8 @@
                 <a:ea typeface="Calibri" pitchFamily="34" charset="-122"/>
                 <a:cs typeface="Calibri" pitchFamily="34" charset="-120"/>
               </a:rPr>
-              <a:t>Submit, then find one FAIL and read the judge's reasoning aloud</a:t>
-            </a:r>
-            <a:endParaRPr lang="en-US" sz="1200" dirty="0"/>
+              <a:t>Portal: submit, then read one FAIL reasoning aloud</a:t>
+            </a:r>
           </a:p>
         </p:txBody>
       </p:sp>
@@ -15846,7 +16628,7 @@
                 <a:ea typeface="Calibri" pitchFamily="34" charset="-122"/>
                 <a:cs typeface="Calibri" pitchFamily="34" charset="-120"/>
               </a:rPr>
-              <a:t>PART B — SDK (30 MIN)</a:t>
+              <a:t>PART B — SDK + ARTIFACTS (25 MIN)</a:t>
             </a:r>
             <a:endParaRPr lang="en-US" sz="1100" dirty="0"/>
           </a:p>
@@ -15885,7 +16667,7 @@
                 <a:ea typeface="Calibri" pitchFamily="34" charset="-122"/>
                 <a:cs typeface="Calibri" pitchFamily="34" charset="-120"/>
               </a:rPr>
-              <a:t>Same dataset, programmatically: criteria → definition → run → poll. This is the exact pattern reused in CI/CD in Module 4. Script: run_cloud_eval.py</a:t>
+              <a:t>run_agent.py builds completed responses; run_cloud_eval.py --precomputed scores them. Export run.json · output-items.jsonl · summary.json for reproducible gates.</a:t>
             </a:r>
             <a:endParaRPr lang="en-US" sz="1200" dirty="0"/>
           </a:p>
@@ -15960,7 +16742,7 @@
                 <a:ea typeface="Calibri" pitchFamily="34" charset="-122"/>
                 <a:cs typeface="Calibri" pitchFamily="34" charset="-120"/>
               </a:rPr>
-              <a:t>Run states &amp; first-aid</a:t>
+              <a:t>Run states, evidence &amp; first-aid</a:t>
             </a:r>
             <a:endParaRPr lang="en-US" sz="1500" dirty="0"/>
           </a:p>
@@ -16002,18 +16784,7 @@
                 <a:ea typeface="Calibri" pitchFamily="34" charset="-122"/>
                 <a:cs typeface="Calibri" pitchFamily="34" charset="-120"/>
               </a:rPr>
-              <a:t>Completed</a:t>
-            </a:r>
-            <a:r>
-              <a:rPr lang="en-US" sz="1200" dirty="0">
-                <a:solidFill>
-                  <a:srgbClr val="CADCFC"/>
-                </a:solidFill>
-                <a:latin typeface="Calibri" pitchFamily="34" charset="0"/>
-                <a:ea typeface="Calibri" pitchFamily="34" charset="-122"/>
-                <a:cs typeface="Calibri" pitchFamily="34" charset="-120"/>
-              </a:rPr>
-              <a:t> — go read reasoning fields</a:t>
+              <a:t>Completed — inspect reasoning + artifacts</a:t>
             </a:r>
             <a:endParaRPr lang="en-US" sz="1200" dirty="0"/>
           </a:p>
@@ -16027,26 +16798,14 @@
             <a:r>
               <a:rPr lang="en-US" sz="1200" b="1" dirty="0">
                 <a:solidFill>
-                  <a:srgbClr val="F5C265"/>
-                </a:solidFill>
-                <a:latin typeface="Calibri" pitchFamily="34" charset="0"/>
-                <a:ea typeface="Calibri" pitchFamily="34" charset="-122"/>
-                <a:cs typeface="Calibri" pitchFamily="34" charset="-120"/>
-              </a:rPr>
-              <a:t>Partial</a:t>
-            </a:r>
-            <a:r>
-              <a:rPr lang="en-US" sz="1200" dirty="0">
-                <a:solidFill>
-                  <a:srgbClr val="CADCFC"/>
-                </a:solidFill>
-                <a:latin typeface="Calibri" pitchFamily="34" charset="0"/>
-                <a:ea typeface="Calibri" pitchFamily="34" charset="-122"/>
-                <a:cs typeface="Calibri" pitchFamily="34" charset="-120"/>
-              </a:rPr>
-              <a:t> — an evaluator failed; usually a data-mapping issue (field names are case-sensitive)</a:t>
-            </a:r>
-            <a:endParaRPr lang="en-US" sz="1200" dirty="0"/>
+                  <a:srgbClr val="7DE3C3"/>
+                </a:solidFill>
+                <a:latin typeface="Calibri" pitchFamily="34" charset="0"/>
+                <a:ea typeface="Calibri" pitchFamily="34" charset="-122"/>
+                <a:cs typeface="Calibri" pitchFamily="34" charset="-120"/>
+              </a:rPr>
+              <a:t>Partial / failed / canceled — never gateable</a:t>
+            </a:r>
           </a:p>
           <a:p>
             <a:pPr marL="0" indent="0">
@@ -16058,26 +16817,14 @@
             <a:r>
               <a:rPr lang="en-US" sz="1200" b="1" dirty="0">
                 <a:solidFill>
-                  <a:srgbClr val="F09B98"/>
-                </a:solidFill>
-                <a:latin typeface="Calibri" pitchFamily="34" charset="0"/>
-                <a:ea typeface="Calibri" pitchFamily="34" charset="-122"/>
-                <a:cs typeface="Calibri" pitchFamily="34" charset="-120"/>
-              </a:rPr>
-              <a:t>Failed</a:t>
-            </a:r>
-            <a:r>
-              <a:rPr lang="en-US" sz="1200" dirty="0">
-                <a:solidFill>
-                  <a:srgbClr val="CADCFC"/>
-                </a:solidFill>
-                <a:latin typeface="Calibri" pitchFamily="34" charset="0"/>
-                <a:ea typeface="Calibri" pitchFamily="34" charset="-122"/>
-                <a:cs typeface="Calibri" pitchFamily="34" charset="-120"/>
-              </a:rPr>
-              <a:t> — check judge-model connection &amp; required fields</a:t>
-            </a:r>
-            <a:endParaRPr lang="en-US" sz="1200" dirty="0"/>
+                  <a:srgbClr val="7DE3C3"/>
+                </a:solidFill>
+                <a:latin typeface="Calibri" pitchFamily="34" charset="0"/>
+                <a:ea typeface="Calibri" pitchFamily="34" charset="-122"/>
+                <a:cs typeface="Calibri" pitchFamily="34" charset="-120"/>
+              </a:rPr>
+              <a:t>429 — honour retry-after; bounded backoff</a:t>
+            </a:r>
           </a:p>
           <a:p>
             <a:pPr marL="0" indent="0">
@@ -16089,26 +16836,14 @@
             <a:r>
               <a:rPr lang="en-US" sz="1200" b="1" dirty="0">
                 <a:solidFill>
-                  <a:srgbClr val="F09B98"/>
-                </a:solidFill>
-                <a:latin typeface="Calibri" pitchFamily="34" charset="0"/>
-                <a:ea typeface="Calibri" pitchFamily="34" charset="-122"/>
-                <a:cs typeface="Calibri" pitchFamily="34" charset="-120"/>
-              </a:rPr>
-              <a:t>429</a:t>
-            </a:r>
-            <a:r>
-              <a:rPr lang="en-US" sz="1200" dirty="0">
-                <a:solidFill>
-                  <a:srgbClr val="CADCFC"/>
-                </a:solidFill>
-                <a:latin typeface="Calibri" pitchFamily="34" charset="0"/>
-                <a:ea typeface="Calibri" pitchFamily="34" charset="-122"/>
-                <a:cs typeface="Calibri" pitchFamily="34" charset="-120"/>
-              </a:rPr>
-              <a:t> — tenant/project rate limit. Honour retry-after, back off. Not your code.</a:t>
-            </a:r>
-            <a:endParaRPr lang="en-US" sz="1200" dirty="0"/>
+                  <a:srgbClr val="7DE3C3"/>
+                </a:solidFill>
+                <a:latin typeface="Calibri" pitchFamily="34" charset="0"/>
+                <a:ea typeface="Calibri" pitchFamily="34" charset="-122"/>
+                <a:cs typeface="Calibri" pitchFamily="34" charset="-120"/>
+              </a:rPr>
+              <a:t>Artifacts — capture run, dataset, judge + criteria provenance</a:t>
+            </a:r>
           </a:p>
         </p:txBody>
       </p:sp>

</xml_diff>